<commit_message>
update: design philosophies PPTX v2 — 15 philosophies x 6 lineages (31 slides), update READMEs accordingly
</commit_message>
<xml_diff>
--- a/examples/design-philosophies/muippt-design-philosophies_202606.pptx
+++ b/examples/design-philosophies/muippt-design-philosophies_202606.pptx
@@ -35,9 +35,7 @@
     <p:sldId id="283" r:id="rId29"/>
     <p:sldId id="284" r:id="rId30"/>
     <p:sldId id="285" r:id="rId31"/>
-    <p:sldId id="286" r:id="rId32"/>
-    <p:sldId id="287" r:id="rId33"/>
-    <p:sldId id="288" r:id="rId34"/>
+    <p:sldId id="288" r:id="rId32"/>
   </p:sldIdLst>
   <p:sldSz cx="12192000" cy="6858000"/>
   <p:notesSz cx="6858000" cy="9144000"/>
@@ -334,7 +332,7 @@
           <a:p>
             <a:fld id="{5BCAD085-E8A6-8845-BD4E-CB4CCA059FC4}" type="datetimeFigureOut">
               <a:rPr lang="en-US" smtClean="0"/>
-              <a:t>4/23/26</a:t>
+              <a:t>6/26/26</a:t>
             </a:fld>
             <a:endParaRPr lang="en-US"/>
           </a:p>
@@ -502,7 +500,7 @@
           <a:p>
             <a:fld id="{5BCAD085-E8A6-8845-BD4E-CB4CCA059FC4}" type="datetimeFigureOut">
               <a:rPr lang="en-US" smtClean="0"/>
-              <a:t>4/23/26</a:t>
+              <a:t>6/26/26</a:t>
             </a:fld>
             <a:endParaRPr lang="en-US"/>
           </a:p>
@@ -680,7 +678,7 @@
           <a:p>
             <a:fld id="{5BCAD085-E8A6-8845-BD4E-CB4CCA059FC4}" type="datetimeFigureOut">
               <a:rPr lang="en-US" smtClean="0"/>
-              <a:t>4/23/26</a:t>
+              <a:t>6/26/26</a:t>
             </a:fld>
             <a:endParaRPr lang="en-US"/>
           </a:p>
@@ -848,7 +846,7 @@
           <a:p>
             <a:fld id="{5BCAD085-E8A6-8845-BD4E-CB4CCA059FC4}" type="datetimeFigureOut">
               <a:rPr lang="en-US" smtClean="0"/>
-              <a:t>4/23/26</a:t>
+              <a:t>6/26/26</a:t>
             </a:fld>
             <a:endParaRPr lang="en-US"/>
           </a:p>
@@ -1093,7 +1091,7 @@
           <a:p>
             <a:fld id="{5BCAD085-E8A6-8845-BD4E-CB4CCA059FC4}" type="datetimeFigureOut">
               <a:rPr lang="en-US" smtClean="0"/>
-              <a:t>4/23/26</a:t>
+              <a:t>6/26/26</a:t>
             </a:fld>
             <a:endParaRPr lang="en-US"/>
           </a:p>
@@ -1378,7 +1376,7 @@
           <a:p>
             <a:fld id="{5BCAD085-E8A6-8845-BD4E-CB4CCA059FC4}" type="datetimeFigureOut">
               <a:rPr lang="en-US" smtClean="0"/>
-              <a:t>4/23/26</a:t>
+              <a:t>6/26/26</a:t>
             </a:fld>
             <a:endParaRPr lang="en-US"/>
           </a:p>
@@ -1797,7 +1795,7 @@
           <a:p>
             <a:fld id="{5BCAD085-E8A6-8845-BD4E-CB4CCA059FC4}" type="datetimeFigureOut">
               <a:rPr lang="en-US" smtClean="0"/>
-              <a:t>4/23/26</a:t>
+              <a:t>6/26/26</a:t>
             </a:fld>
             <a:endParaRPr lang="en-US"/>
           </a:p>
@@ -1914,7 +1912,7 @@
           <a:p>
             <a:fld id="{5BCAD085-E8A6-8845-BD4E-CB4CCA059FC4}" type="datetimeFigureOut">
               <a:rPr lang="en-US" smtClean="0"/>
-              <a:t>4/23/26</a:t>
+              <a:t>6/26/26</a:t>
             </a:fld>
             <a:endParaRPr lang="en-US"/>
           </a:p>
@@ -2009,7 +2007,7 @@
           <a:p>
             <a:fld id="{5BCAD085-E8A6-8845-BD4E-CB4CCA059FC4}" type="datetimeFigureOut">
               <a:rPr lang="en-US" smtClean="0"/>
-              <a:t>4/23/26</a:t>
+              <a:t>6/26/26</a:t>
             </a:fld>
             <a:endParaRPr lang="en-US"/>
           </a:p>
@@ -2284,7 +2282,7 @@
           <a:p>
             <a:fld id="{5BCAD085-E8A6-8845-BD4E-CB4CCA059FC4}" type="datetimeFigureOut">
               <a:rPr lang="en-US" smtClean="0"/>
-              <a:t>4/23/26</a:t>
+              <a:t>6/26/26</a:t>
             </a:fld>
             <a:endParaRPr lang="en-US"/>
           </a:p>
@@ -2536,7 +2534,7 @@
           <a:p>
             <a:fld id="{5BCAD085-E8A6-8845-BD4E-CB4CCA059FC4}" type="datetimeFigureOut">
               <a:rPr lang="en-US" smtClean="0"/>
-              <a:t>4/23/26</a:t>
+              <a:t>6/26/26</a:t>
             </a:fld>
             <a:endParaRPr lang="en-US"/>
           </a:p>
@@ -2747,7 +2745,7 @@
           <a:p>
             <a:fld id="{5BCAD085-E8A6-8845-BD4E-CB4CCA059FC4}" type="datetimeFigureOut">
               <a:rPr lang="en-US" smtClean="0"/>
-              <a:t>4/23/26</a:t>
+              <a:t>6/26/26</a:t>
             </a:fld>
             <a:endParaRPr lang="en-US"/>
           </a:p>
@@ -3183,7 +3181,7 @@
         <p:spPr>
           <a:xfrm>
             <a:off x="552450" y="1457325"/>
-            <a:ext cx="2569869" cy="3352800"/>
+            <a:ext cx="2353208" cy="2539157"/>
           </a:xfrm>
           <a:prstGeom prst="rect">
             <a:avLst/>
@@ -3211,8 +3209,31 @@
                 <a:ea typeface="Microsoft YaHei"/>
                 <a:cs typeface="Arial"/>
               </a:rPr>
-              <a:t>15</a:t>
-            </a:r>
+              <a:t>1</a:t>
+            </a:r>
+            <a:r>
+              <a:rPr lang="en-US" altLang="zh-CN" sz="16500" b="1" dirty="0">
+                <a:solidFill>
+                  <a:srgbClr val="003366">
+                    <a:alpha val="6000"/>
+                  </a:srgbClr>
+                </a:solidFill>
+                <a:latin typeface="Arial"/>
+                <a:ea typeface="Microsoft YaHei"/>
+                <a:cs typeface="Arial"/>
+              </a:rPr>
+              <a:t>4</a:t>
+            </a:r>
+            <a:endParaRPr lang="zh-CN" sz="16500" b="1" dirty="0">
+              <a:solidFill>
+                <a:srgbClr val="003366">
+                  <a:alpha val="6000"/>
+                </a:srgbClr>
+              </a:solidFill>
+              <a:latin typeface="Arial"/>
+              <a:ea typeface="Microsoft YaHei"/>
+              <a:cs typeface="Arial"/>
+            </a:endParaRPr>
           </a:p>
         </p:txBody>
       </p:sp>
@@ -3225,7 +3246,7 @@
         <p:spPr>
           <a:xfrm>
             <a:off x="701040" y="2339340"/>
-            <a:ext cx="3029483" cy="975360"/>
+            <a:ext cx="2428550" cy="738664"/>
           </a:xfrm>
           <a:prstGeom prst="rect">
             <a:avLst/>
@@ -3251,8 +3272,27 @@
                 <a:ea typeface="Microsoft YaHei"/>
                 <a:cs typeface="Arial"/>
               </a:rPr>
-              <a:t>PPT 大师</a:t>
-            </a:r>
+              <a:t>PPT</a:t>
+            </a:r>
+            <a:r>
+              <a:rPr lang="zh-CN" altLang="en-US" sz="4800" b="1" dirty="0">
+                <a:solidFill>
+                  <a:srgbClr val="003366"/>
+                </a:solidFill>
+                <a:latin typeface="Arial"/>
+                <a:ea typeface="Microsoft YaHei"/>
+                <a:cs typeface="Arial"/>
+              </a:rPr>
+              <a:t>美学</a:t>
+            </a:r>
+            <a:endParaRPr lang="zh-CN" sz="4800" b="1" dirty="0">
+              <a:solidFill>
+                <a:srgbClr val="003366"/>
+              </a:solidFill>
+              <a:latin typeface="Arial"/>
+              <a:ea typeface="Microsoft YaHei"/>
+              <a:cs typeface="Arial"/>
+            </a:endParaRPr>
           </a:p>
         </p:txBody>
       </p:sp>
@@ -3305,7 +3345,7 @@
         <p:spPr>
           <a:xfrm>
             <a:off x="739140" y="3996690"/>
-            <a:ext cx="3016377" cy="365760"/>
+            <a:ext cx="2697854" cy="276999"/>
           </a:xfrm>
           <a:prstGeom prst="rect">
             <a:avLst/>
@@ -3331,7 +3371,40 @@
                 <a:ea typeface="Microsoft YaHei"/>
                 <a:cs typeface="Arial"/>
               </a:rPr>
-              <a:t>15 种设计哲学 × 以身说法</a:t>
+              <a:t>1</a:t>
+            </a:r>
+            <a:r>
+              <a:rPr lang="en-US" altLang="zh-CN" sz="1800">
+                <a:solidFill>
+                  <a:srgbClr val="666666"/>
+                </a:solidFill>
+                <a:latin typeface="Arial"/>
+                <a:ea typeface="Microsoft YaHei"/>
+                <a:cs typeface="Arial"/>
+              </a:rPr>
+              <a:t>4</a:t>
+            </a:r>
+            <a:r>
+              <a:rPr lang="zh-CN" sz="1800">
+                <a:solidFill>
+                  <a:srgbClr val="666666"/>
+                </a:solidFill>
+                <a:latin typeface="Arial"/>
+                <a:ea typeface="Microsoft YaHei"/>
+                <a:cs typeface="Arial"/>
+              </a:rPr>
+              <a:t> </a:t>
+            </a:r>
+            <a:r>
+              <a:rPr lang="zh-CN" sz="1800" dirty="0">
+                <a:solidFill>
+                  <a:srgbClr val="666666"/>
+                </a:solidFill>
+                <a:latin typeface="Arial"/>
+                <a:ea typeface="Microsoft YaHei"/>
+                <a:cs typeface="Arial"/>
+              </a:rPr>
+              <a:t>种设计哲学 × 以身说法</a:t>
             </a:r>
           </a:p>
         </p:txBody>
@@ -3345,7 +3418,7 @@
         <p:spPr>
           <a:xfrm>
             <a:off x="746760" y="5775960"/>
-            <a:ext cx="4008882" cy="243840"/>
+            <a:ext cx="554639" cy="184666"/>
           </a:xfrm>
           <a:prstGeom prst="rect">
             <a:avLst/>
@@ -3371,7 +3444,29 @@
                 <a:ea typeface="Microsoft YaHei"/>
                 <a:cs typeface="Arial"/>
               </a:rPr>
-              <a:t>mu-ppt-master | Design Philosophies Collection</a:t>
+              <a:t>mu-</a:t>
+            </a:r>
+            <a:r>
+              <a:rPr lang="en-US" altLang="zh-CN" sz="1200" dirty="0" err="1">
+                <a:solidFill>
+                  <a:srgbClr val="999999"/>
+                </a:solidFill>
+                <a:latin typeface="Arial"/>
+                <a:ea typeface="Microsoft YaHei"/>
+                <a:cs typeface="Arial"/>
+              </a:rPr>
+              <a:t>i</a:t>
+            </a:r>
+            <a:r>
+              <a:rPr lang="zh-CN" sz="1200" dirty="0">
+                <a:solidFill>
+                  <a:srgbClr val="999999"/>
+                </a:solidFill>
+                <a:latin typeface="Arial"/>
+                <a:ea typeface="Microsoft YaHei"/>
+                <a:cs typeface="Arial"/>
+              </a:rPr>
+              <a:t>ppt </a:t>
             </a:r>
           </a:p>
         </p:txBody>
@@ -31069,3054 +31164,6 @@
       </p:sp>
       <p:sp>
         <p:nvSpPr>
-          <p:cNvPr id="3" name="Rectangle 3"/>
-          <p:cNvSpPr/>
-          <p:nvPr/>
-        </p:nvSpPr>
-        <p:spPr>
-          <a:xfrm>
-            <a:off x="0" y="0"/>
-            <a:ext cx="12192000" cy="57150"/>
-          </a:xfrm>
-          <a:prstGeom prst="rect">
-            <a:avLst/>
-          </a:prstGeom>
-          <a:solidFill>
-            <a:srgbClr val="FFD100"/>
-          </a:solidFill>
-          <a:ln>
-            <a:noFill/>
-          </a:ln>
-        </p:spPr>
-      </p:sp>
-      <p:sp>
-        <p:nvSpPr>
-          <p:cNvPr id="4" name="Freeform 4"/>
-          <p:cNvSpPr/>
-          <p:nvPr/>
-        </p:nvSpPr>
-        <p:spPr>
-          <a:xfrm>
-            <a:off x="762000" y="2667000"/>
-            <a:ext cx="533400" cy="533400"/>
-          </a:xfrm>
-          <a:custGeom>
-            <a:avLst/>
-            <a:gdLst/>
-            <a:ahLst/>
-            <a:cxnLst/>
-            <a:rect l="l" t="t" r="r" b="b"/>
-            <a:pathLst>
-              <a:path w="533400" h="533400">
-                <a:moveTo>
-                  <a:pt x="114300" y="0"/>
-                </a:moveTo>
-                <a:lnTo>
-                  <a:pt x="419100" y="0"/>
-                </a:lnTo>
-                <a:cubicBezTo>
-                  <a:pt x="482226" y="0"/>
-                  <a:pt x="533400" y="51174"/>
-                  <a:pt x="533400" y="114300"/>
-                </a:cubicBezTo>
-                <a:lnTo>
-                  <a:pt x="533400" y="419100"/>
-                </a:lnTo>
-                <a:cubicBezTo>
-                  <a:pt x="533400" y="482226"/>
-                  <a:pt x="482226" y="533400"/>
-                  <a:pt x="419100" y="533400"/>
-                </a:cubicBezTo>
-                <a:lnTo>
-                  <a:pt x="114300" y="533400"/>
-                </a:lnTo>
-                <a:cubicBezTo>
-                  <a:pt x="51174" y="533400"/>
-                  <a:pt x="0" y="482226"/>
-                  <a:pt x="0" y="419100"/>
-                </a:cubicBezTo>
-                <a:lnTo>
-                  <a:pt x="0" y="114300"/>
-                </a:lnTo>
-                <a:cubicBezTo>
-                  <a:pt x="0" y="51174"/>
-                  <a:pt x="51174" y="0"/>
-                  <a:pt x="114300" y="0"/>
-                </a:cubicBezTo>
-                <a:close/>
-              </a:path>
-            </a:pathLst>
-          </a:custGeom>
-          <a:solidFill>
-            <a:srgbClr val="FFD100"/>
-          </a:solidFill>
-          <a:ln>
-            <a:noFill/>
-          </a:ln>
-        </p:spPr>
-      </p:sp>
-      <p:sp>
-        <p:nvSpPr>
-          <p:cNvPr id="5" name="TextBox 5"/>
-          <p:cNvSpPr txBox="1"/>
-          <p:nvPr/>
-        </p:nvSpPr>
-        <p:spPr>
-          <a:xfrm>
-            <a:off x="888525" y="2825115"/>
-            <a:ext cx="280349" cy="365760"/>
-          </a:xfrm>
-          <a:prstGeom prst="rect">
-            <a:avLst/>
-          </a:prstGeom>
-          <a:noFill/>
-          <a:ln>
-            <a:noFill/>
-          </a:ln>
-        </p:spPr>
-        <p:txBody>
-          <a:bodyPr wrap="none" lIns="0" tIns="0" rIns="0" bIns="0" anchor="t" anchorCtr="0">
-            <a:spAutoFit/>
-          </a:bodyPr>
-          <a:lstStyle/>
-          <a:p>
-            <a:pPr algn="ctr"/>
-            <a:r>
-              <a:rPr lang="zh-CN" sz="1800" b="1" dirty="0">
-                <a:solidFill>
-                  <a:srgbClr val="000000"/>
-                </a:solidFill>
-                <a:latin typeface="Arial"/>
-                <a:ea typeface="Microsoft YaHei"/>
-                <a:cs typeface="Arial"/>
-              </a:rPr>
-              <a:t>15</a:t>
-            </a:r>
-          </a:p>
-        </p:txBody>
-      </p:sp>
-      <p:sp>
-        <p:nvSpPr>
-          <p:cNvPr id="6" name="TextBox 6"/>
-          <p:cNvSpPr txBox="1"/>
-          <p:nvPr/>
-        </p:nvSpPr>
-        <p:spPr>
-          <a:xfrm>
-            <a:off x="1463040" y="2510790"/>
-            <a:ext cx="2919070" cy="975360"/>
-          </a:xfrm>
-          <a:prstGeom prst="rect">
-            <a:avLst/>
-          </a:prstGeom>
-          <a:noFill/>
-          <a:ln>
-            <a:noFill/>
-          </a:ln>
-        </p:spPr>
-        <p:txBody>
-          <a:bodyPr wrap="none" lIns="0" tIns="0" rIns="0" bIns="0" anchor="t" anchorCtr="0">
-            <a:spAutoFit/>
-          </a:bodyPr>
-          <a:lstStyle/>
-          <a:p>
-            <a:pPr algn="l"/>
-            <a:r>
-              <a:rPr lang="zh-CN" sz="4800" b="1" dirty="0">
-                <a:solidFill>
-                  <a:srgbClr val="000000"/>
-                </a:solidFill>
-                <a:latin typeface="Arial"/>
-                <a:ea typeface="Microsoft YaHei"/>
-                <a:cs typeface="Arial"/>
-              </a:rPr>
-              <a:t>Meituan</a:t>
-            </a:r>
-          </a:p>
-        </p:txBody>
-      </p:sp>
-      <p:sp>
-        <p:nvSpPr>
-          <p:cNvPr id="7" name="TextBox 7"/>
-          <p:cNvSpPr txBox="1"/>
-          <p:nvPr/>
-        </p:nvSpPr>
-        <p:spPr>
-          <a:xfrm>
-            <a:off x="1495425" y="3376612"/>
-            <a:ext cx="1371600" cy="457200"/>
-          </a:xfrm>
-          <a:prstGeom prst="rect">
-            <a:avLst/>
-          </a:prstGeom>
-          <a:noFill/>
-          <a:ln>
-            <a:noFill/>
-          </a:ln>
-        </p:spPr>
-        <p:txBody>
-          <a:bodyPr wrap="none" lIns="0" tIns="0" rIns="0" bIns="0" anchor="t" anchorCtr="0">
-            <a:spAutoFit/>
-          </a:bodyPr>
-          <a:lstStyle/>
-          <a:p>
-            <a:pPr algn="l"/>
-            <a:r>
-              <a:rPr lang="zh-CN" sz="2250" dirty="0">
-                <a:solidFill>
-                  <a:srgbClr val="000000">
-                    <a:alpha val="60000"/>
-                  </a:srgbClr>
-                </a:solidFill>
-                <a:latin typeface="Arial"/>
-                <a:ea typeface="Microsoft YaHei"/>
-                <a:cs typeface="Arial"/>
-              </a:rPr>
-              <a:t>阳光活力</a:t>
-            </a:r>
-          </a:p>
-        </p:txBody>
-      </p:sp>
-      <p:sp>
-        <p:nvSpPr>
-          <p:cNvPr id="8" name="Freeform 8"/>
-          <p:cNvSpPr/>
-          <p:nvPr/>
-        </p:nvSpPr>
-        <p:spPr>
-          <a:xfrm>
-            <a:off x="1524000" y="3810000"/>
-            <a:ext cx="1524000" cy="266700"/>
-          </a:xfrm>
-          <a:custGeom>
-            <a:avLst/>
-            <a:gdLst/>
-            <a:ahLst/>
-            <a:cxnLst/>
-            <a:rect l="l" t="t" r="r" b="b"/>
-            <a:pathLst>
-              <a:path w="1524000" h="266700">
-                <a:moveTo>
-                  <a:pt x="76200" y="0"/>
-                </a:moveTo>
-                <a:lnTo>
-                  <a:pt x="1447800" y="0"/>
-                </a:lnTo>
-                <a:cubicBezTo>
-                  <a:pt x="1489884" y="0"/>
-                  <a:pt x="1524000" y="34116"/>
-                  <a:pt x="1524000" y="76200"/>
-                </a:cubicBezTo>
-                <a:lnTo>
-                  <a:pt x="1524000" y="190500"/>
-                </a:lnTo>
-                <a:cubicBezTo>
-                  <a:pt x="1524000" y="232584"/>
-                  <a:pt x="1489884" y="266700"/>
-                  <a:pt x="1447800" y="266700"/>
-                </a:cubicBezTo>
-                <a:lnTo>
-                  <a:pt x="76200" y="266700"/>
-                </a:lnTo>
-                <a:cubicBezTo>
-                  <a:pt x="34116" y="266700"/>
-                  <a:pt x="0" y="232584"/>
-                  <a:pt x="0" y="190500"/>
-                </a:cubicBezTo>
-                <a:lnTo>
-                  <a:pt x="0" y="76200"/>
-                </a:lnTo>
-                <a:cubicBezTo>
-                  <a:pt x="0" y="34116"/>
-                  <a:pt x="34116" y="0"/>
-                  <a:pt x="76200" y="0"/>
-                </a:cubicBezTo>
-                <a:close/>
-              </a:path>
-            </a:pathLst>
-          </a:custGeom>
-          <a:solidFill>
-            <a:srgbClr val="FFD100">
-              <a:alpha val="20000"/>
-            </a:srgbClr>
-          </a:solidFill>
-          <a:ln>
-            <a:noFill/>
-          </a:ln>
-        </p:spPr>
-      </p:sp>
-      <p:sp>
-        <p:nvSpPr>
-          <p:cNvPr id="9" name="TextBox 9"/>
-          <p:cNvSpPr txBox="1"/>
-          <p:nvPr/>
-        </p:nvSpPr>
-        <p:spPr>
-          <a:xfrm>
-            <a:off x="1846421" y="3895249"/>
-            <a:ext cx="879157" cy="198120"/>
-          </a:xfrm>
-          <a:prstGeom prst="rect">
-            <a:avLst/>
-          </a:prstGeom>
-          <a:noFill/>
-          <a:ln>
-            <a:noFill/>
-          </a:ln>
-        </p:spPr>
-        <p:txBody>
-          <a:bodyPr wrap="none" lIns="0" tIns="0" rIns="0" bIns="0" anchor="t" anchorCtr="0">
-            <a:spAutoFit/>
-          </a:bodyPr>
-          <a:lstStyle/>
-          <a:p>
-            <a:pPr algn="ctr"/>
-            <a:r>
-              <a:rPr lang="zh-CN" sz="975" dirty="0">
-                <a:solidFill>
-                  <a:srgbClr val="000000">
-                    <a:alpha val="60000"/>
-                  </a:srgbClr>
-                </a:solidFill>
-                <a:latin typeface="Arial"/>
-                <a:ea typeface="Microsoft YaHei"/>
-                <a:cs typeface="Arial"/>
-              </a:rPr>
-              <a:t>品牌原生流派</a:t>
-            </a:r>
-          </a:p>
-        </p:txBody>
-      </p:sp>
-      <p:sp>
-        <p:nvSpPr>
-          <p:cNvPr id="10" name="TextBox 10"/>
-          <p:cNvSpPr txBox="1"/>
-          <p:nvPr/>
-        </p:nvSpPr>
-        <p:spPr>
-          <a:xfrm>
-            <a:off x="1510665" y="4458652"/>
-            <a:ext cx="1307163" cy="213360"/>
-          </a:xfrm>
-          <a:prstGeom prst="rect">
-            <a:avLst/>
-          </a:prstGeom>
-          <a:noFill/>
-          <a:ln>
-            <a:noFill/>
-          </a:ln>
-        </p:spPr>
-        <p:txBody>
-          <a:bodyPr wrap="none" lIns="0" tIns="0" rIns="0" bIns="0" anchor="t" anchorCtr="0">
-            <a:spAutoFit/>
-          </a:bodyPr>
-          <a:lstStyle/>
-          <a:p>
-            <a:pPr algn="l"/>
-            <a:r>
-              <a:rPr lang="zh-CN" sz="1050" dirty="0">
-                <a:solidFill>
-                  <a:srgbClr val="000000">
-                    <a:alpha val="20000"/>
-                  </a:srgbClr>
-                </a:solidFill>
-                <a:latin typeface="Arial"/>
-                <a:ea typeface="Microsoft YaHei"/>
-                <a:cs typeface="Arial"/>
-              </a:rPr>
-              <a:t>SUNSHINE VITALITY</a:t>
-            </a:r>
-          </a:p>
-        </p:txBody>
-      </p:sp>
-      <p:sp>
-        <p:nvSpPr>
-          <p:cNvPr id="11" name="Freeform 11"/>
-          <p:cNvSpPr/>
-          <p:nvPr/>
-        </p:nvSpPr>
-        <p:spPr>
-          <a:xfrm>
-            <a:off x="9334500" y="1936750"/>
-            <a:ext cx="381000" cy="444500"/>
-          </a:xfrm>
-          <a:custGeom>
-            <a:avLst/>
-            <a:gdLst/>
-            <a:ahLst/>
-            <a:cxnLst/>
-            <a:rect l="l" t="t" r="r" b="b"/>
-            <a:pathLst>
-              <a:path w="381000" h="444500">
-                <a:moveTo>
-                  <a:pt x="0" y="444500"/>
-                </a:moveTo>
-                <a:cubicBezTo>
-                  <a:pt x="127000" y="0"/>
-                  <a:pt x="254000" y="0"/>
-                  <a:pt x="381000" y="444500"/>
-                </a:cubicBezTo>
-              </a:path>
-            </a:pathLst>
-          </a:custGeom>
-          <a:noFill/>
-          <a:ln w="28575">
-            <a:solidFill>
-              <a:srgbClr val="FFD100">
-                <a:alpha val="15000"/>
-              </a:srgbClr>
-            </a:solidFill>
-          </a:ln>
-        </p:spPr>
-      </p:sp>
-      <p:sp>
-        <p:nvSpPr>
-          <p:cNvPr id="12" name="Freeform 12"/>
-          <p:cNvSpPr/>
-          <p:nvPr/>
-        </p:nvSpPr>
-        <p:spPr>
-          <a:xfrm>
-            <a:off x="10001250" y="1936750"/>
-            <a:ext cx="381000" cy="444500"/>
-          </a:xfrm>
-          <a:custGeom>
-            <a:avLst/>
-            <a:gdLst/>
-            <a:ahLst/>
-            <a:cxnLst/>
-            <a:rect l="l" t="t" r="r" b="b"/>
-            <a:pathLst>
-              <a:path w="381000" h="444500">
-                <a:moveTo>
-                  <a:pt x="0" y="444500"/>
-                </a:moveTo>
-                <a:cubicBezTo>
-                  <a:pt x="127000" y="0"/>
-                  <a:pt x="254000" y="0"/>
-                  <a:pt x="381000" y="444500"/>
-                </a:cubicBezTo>
-              </a:path>
-            </a:pathLst>
-          </a:custGeom>
-          <a:noFill/>
-          <a:ln w="28575">
-            <a:solidFill>
-              <a:srgbClr val="FFD100">
-                <a:alpha val="15000"/>
-              </a:srgbClr>
-            </a:solidFill>
-          </a:ln>
-        </p:spPr>
-      </p:sp>
-      <p:sp>
-        <p:nvSpPr>
-          <p:cNvPr id="13" name="Freeform 13"/>
-          <p:cNvSpPr/>
-          <p:nvPr/>
-        </p:nvSpPr>
-        <p:spPr>
-          <a:xfrm>
-            <a:off x="9144000" y="2667000"/>
-            <a:ext cx="1428750" cy="1428750"/>
-          </a:xfrm>
-          <a:custGeom>
-            <a:avLst/>
-            <a:gdLst/>
-            <a:ahLst/>
-            <a:cxnLst/>
-            <a:rect l="l" t="t" r="r" b="b"/>
-            <a:pathLst>
-              <a:path w="1428750" h="1428750">
-                <a:moveTo>
-                  <a:pt x="304800" y="0"/>
-                </a:moveTo>
-                <a:lnTo>
-                  <a:pt x="1123950" y="0"/>
-                </a:lnTo>
-                <a:cubicBezTo>
-                  <a:pt x="1292286" y="0"/>
-                  <a:pt x="1428750" y="136464"/>
-                  <a:pt x="1428750" y="304800"/>
-                </a:cubicBezTo>
-                <a:lnTo>
-                  <a:pt x="1428750" y="1123950"/>
-                </a:lnTo>
-                <a:cubicBezTo>
-                  <a:pt x="1428750" y="1292286"/>
-                  <a:pt x="1292286" y="1428750"/>
-                  <a:pt x="1123950" y="1428750"/>
-                </a:cubicBezTo>
-                <a:lnTo>
-                  <a:pt x="304800" y="1428750"/>
-                </a:lnTo>
-                <a:cubicBezTo>
-                  <a:pt x="136464" y="1428750"/>
-                  <a:pt x="0" y="1292286"/>
-                  <a:pt x="0" y="1123950"/>
-                </a:cubicBezTo>
-                <a:lnTo>
-                  <a:pt x="0" y="304800"/>
-                </a:lnTo>
-                <a:cubicBezTo>
-                  <a:pt x="0" y="136464"/>
-                  <a:pt x="136464" y="0"/>
-                  <a:pt x="304800" y="0"/>
-                </a:cubicBezTo>
-                <a:close/>
-              </a:path>
-            </a:pathLst>
-          </a:custGeom>
-          <a:solidFill>
-            <a:srgbClr val="FFD100">
-              <a:alpha val="6000"/>
-            </a:srgbClr>
-          </a:solidFill>
-          <a:ln>
-            <a:noFill/>
-          </a:ln>
-        </p:spPr>
-      </p:sp>
-      <p:sp>
-        <p:nvSpPr>
-          <p:cNvPr id="14" name="Rectangle 14"/>
-          <p:cNvSpPr/>
-          <p:nvPr/>
-        </p:nvSpPr>
-        <p:spPr>
-          <a:xfrm>
-            <a:off x="0" y="6477000"/>
-            <a:ext cx="12192000" cy="381000"/>
-          </a:xfrm>
-          <a:prstGeom prst="rect">
-            <a:avLst/>
-          </a:prstGeom>
-          <a:solidFill>
-            <a:srgbClr val="FFFFFF"/>
-          </a:solidFill>
-          <a:ln>
-            <a:noFill/>
-          </a:ln>
-        </p:spPr>
-      </p:sp>
-      <p:sp>
-        <p:nvSpPr>
-          <p:cNvPr id="15" name="Rectangle 15"/>
-          <p:cNvSpPr/>
-          <p:nvPr/>
-        </p:nvSpPr>
-        <p:spPr>
-          <a:xfrm>
-            <a:off x="0" y="6477000"/>
-            <a:ext cx="12192000" cy="9525"/>
-          </a:xfrm>
-          <a:prstGeom prst="rect">
-            <a:avLst/>
-          </a:prstGeom>
-          <a:solidFill>
-            <a:srgbClr val="F0F0F0"/>
-          </a:solidFill>
-          <a:ln>
-            <a:noFill/>
-          </a:ln>
-        </p:spPr>
-      </p:sp>
-      <p:sp>
-        <p:nvSpPr>
-          <p:cNvPr id="16" name="Freeform 16"/>
-          <p:cNvSpPr/>
-          <p:nvPr/>
-        </p:nvSpPr>
-        <p:spPr>
-          <a:xfrm>
-            <a:off x="571500" y="6572250"/>
-            <a:ext cx="228600" cy="228600"/>
-          </a:xfrm>
-          <a:custGeom>
-            <a:avLst/>
-            <a:gdLst/>
-            <a:ahLst/>
-            <a:cxnLst/>
-            <a:rect l="l" t="t" r="r" b="b"/>
-            <a:pathLst>
-              <a:path w="228600" h="228600">
-                <a:moveTo>
-                  <a:pt x="57150" y="0"/>
-                </a:moveTo>
-                <a:lnTo>
-                  <a:pt x="171450" y="0"/>
-                </a:lnTo>
-                <a:cubicBezTo>
-                  <a:pt x="203013" y="0"/>
-                  <a:pt x="228600" y="25587"/>
-                  <a:pt x="228600" y="57150"/>
-                </a:cubicBezTo>
-                <a:lnTo>
-                  <a:pt x="228600" y="171450"/>
-                </a:lnTo>
-                <a:cubicBezTo>
-                  <a:pt x="228600" y="203013"/>
-                  <a:pt x="203013" y="228600"/>
-                  <a:pt x="171450" y="228600"/>
-                </a:cubicBezTo>
-                <a:lnTo>
-                  <a:pt x="57150" y="228600"/>
-                </a:lnTo>
-                <a:cubicBezTo>
-                  <a:pt x="25587" y="228600"/>
-                  <a:pt x="0" y="203013"/>
-                  <a:pt x="0" y="171450"/>
-                </a:cubicBezTo>
-                <a:lnTo>
-                  <a:pt x="0" y="57150"/>
-                </a:lnTo>
-                <a:cubicBezTo>
-                  <a:pt x="0" y="25587"/>
-                  <a:pt x="25587" y="0"/>
-                  <a:pt x="57150" y="0"/>
-                </a:cubicBezTo>
-                <a:close/>
-              </a:path>
-            </a:pathLst>
-          </a:custGeom>
-          <a:solidFill>
-            <a:srgbClr val="FFD100"/>
-          </a:solidFill>
-          <a:ln>
-            <a:noFill/>
-          </a:ln>
-        </p:spPr>
-      </p:sp>
-      <p:sp>
-        <p:nvSpPr>
-          <p:cNvPr id="17" name="TextBox 17"/>
-          <p:cNvSpPr txBox="1"/>
-          <p:nvPr/>
-        </p:nvSpPr>
-        <p:spPr>
-          <a:xfrm>
-            <a:off x="863918" y="6638449"/>
-            <a:ext cx="309562" cy="198120"/>
-          </a:xfrm>
-          <a:prstGeom prst="rect">
-            <a:avLst/>
-          </a:prstGeom>
-          <a:noFill/>
-          <a:ln>
-            <a:noFill/>
-          </a:ln>
-        </p:spPr>
-        <p:txBody>
-          <a:bodyPr wrap="none" lIns="0" tIns="0" rIns="0" bIns="0" anchor="t" anchorCtr="0">
-            <a:spAutoFit/>
-          </a:bodyPr>
-          <a:lstStyle/>
-          <a:p>
-            <a:pPr algn="l"/>
-            <a:r>
-              <a:rPr lang="zh-CN" sz="975" dirty="0">
-                <a:solidFill>
-                  <a:srgbClr val="000000">
-                    <a:alpha val="40000"/>
-                  </a:srgbClr>
-                </a:solidFill>
-                <a:latin typeface="Arial"/>
-                <a:ea typeface="Microsoft YaHei"/>
-                <a:cs typeface="Arial"/>
-              </a:rPr>
-              <a:t>美团</a:t>
-            </a:r>
-          </a:p>
-        </p:txBody>
-      </p:sp>
-      <p:sp>
-        <p:nvSpPr>
-          <p:cNvPr id="18" name="TextBox 18"/>
-          <p:cNvSpPr txBox="1"/>
-          <p:nvPr/>
-        </p:nvSpPr>
-        <p:spPr>
-          <a:xfrm>
-            <a:off x="11306842" y="6646545"/>
-            <a:ext cx="134588" cy="182880"/>
-          </a:xfrm>
-          <a:prstGeom prst="rect">
-            <a:avLst/>
-          </a:prstGeom>
-          <a:noFill/>
-          <a:ln>
-            <a:noFill/>
-          </a:ln>
-        </p:spPr>
-        <p:txBody>
-          <a:bodyPr wrap="none" lIns="0" tIns="0" rIns="0" bIns="0" anchor="t" anchorCtr="0">
-            <a:spAutoFit/>
-          </a:bodyPr>
-          <a:lstStyle/>
-          <a:p>
-            <a:pPr algn="r"/>
-            <a:r>
-              <a:rPr lang="zh-CN" sz="900" dirty="0">
-                <a:solidFill>
-                  <a:srgbClr val="CCCCCC"/>
-                </a:solidFill>
-                <a:latin typeface="Arial"/>
-                <a:ea typeface="Microsoft YaHei"/>
-                <a:cs typeface="Arial"/>
-              </a:rPr>
-              <a:t>31</a:t>
-            </a:r>
-          </a:p>
-        </p:txBody>
-      </p:sp>
-    </p:spTree>
-  </p:cSld>
-  <p:clrMapOvr>
-    <a:masterClrMapping/>
-  </p:clrMapOvr>
-  <p:transition>
-    <p:fade/>
-  </p:transition>
-</p:sld>
-</file>
-
-<file path=ppt/slides/slide32.xml><?xml version="1.0" encoding="utf-8"?>
-<p:sld xmlns:a="http://schemas.openxmlformats.org/drawingml/2006/main" xmlns:r="http://schemas.openxmlformats.org/officeDocument/2006/relationships" xmlns:p="http://schemas.openxmlformats.org/presentationml/2006/main">
-  <p:cSld>
-    <p:spTree>
-      <p:nvGrpSpPr>
-        <p:cNvPr id="1" name=""/>
-        <p:cNvGrpSpPr/>
-        <p:nvPr/>
-      </p:nvGrpSpPr>
-      <p:grpSpPr>
-        <a:xfrm>
-          <a:off x="0" y="0"/>
-          <a:ext cx="0" cy="0"/>
-          <a:chOff x="0" y="0"/>
-          <a:chExt cx="0" cy="0"/>
-        </a:xfrm>
-      </p:grpSpPr>
-      <p:sp>
-        <p:nvSpPr>
-          <p:cNvPr id="2" name="Rectangle 2"/>
-          <p:cNvSpPr/>
-          <p:nvPr/>
-        </p:nvSpPr>
-        <p:spPr>
-          <a:xfrm>
-            <a:off x="0" y="0"/>
-            <a:ext cx="12192000" cy="6858000"/>
-          </a:xfrm>
-          <a:prstGeom prst="rect">
-            <a:avLst/>
-          </a:prstGeom>
-          <a:solidFill>
-            <a:srgbClr val="FFFFFF"/>
-          </a:solidFill>
-          <a:ln>
-            <a:noFill/>
-          </a:ln>
-        </p:spPr>
-      </p:sp>
-      <p:sp>
-        <p:nvSpPr>
-          <p:cNvPr id="3" name="Rectangle 3"/>
-          <p:cNvSpPr/>
-          <p:nvPr/>
-        </p:nvSpPr>
-        <p:spPr>
-          <a:xfrm>
-            <a:off x="0" y="0"/>
-            <a:ext cx="12192000" cy="38100"/>
-          </a:xfrm>
-          <a:prstGeom prst="rect">
-            <a:avLst/>
-          </a:prstGeom>
-          <a:solidFill>
-            <a:srgbClr val="FFD100"/>
-          </a:solidFill>
-          <a:ln>
-            <a:noFill/>
-          </a:ln>
-        </p:spPr>
-      </p:sp>
-      <p:sp>
-        <p:nvSpPr>
-          <p:cNvPr id="4" name="Freeform 4"/>
-          <p:cNvSpPr/>
-          <p:nvPr/>
-        </p:nvSpPr>
-        <p:spPr>
-          <a:xfrm>
-            <a:off x="762000" y="285750"/>
-            <a:ext cx="342900" cy="209550"/>
-          </a:xfrm>
-          <a:custGeom>
-            <a:avLst/>
-            <a:gdLst/>
-            <a:ahLst/>
-            <a:cxnLst/>
-            <a:rect l="l" t="t" r="r" b="b"/>
-            <a:pathLst>
-              <a:path w="342900" h="209550">
-                <a:moveTo>
-                  <a:pt x="57150" y="0"/>
-                </a:moveTo>
-                <a:lnTo>
-                  <a:pt x="285750" y="0"/>
-                </a:lnTo>
-                <a:cubicBezTo>
-                  <a:pt x="317313" y="0"/>
-                  <a:pt x="342900" y="25587"/>
-                  <a:pt x="342900" y="57150"/>
-                </a:cubicBezTo>
-                <a:lnTo>
-                  <a:pt x="342900" y="152400"/>
-                </a:lnTo>
-                <a:cubicBezTo>
-                  <a:pt x="342900" y="183963"/>
-                  <a:pt x="317313" y="209550"/>
-                  <a:pt x="285750" y="209550"/>
-                </a:cubicBezTo>
-                <a:lnTo>
-                  <a:pt x="57150" y="209550"/>
-                </a:lnTo>
-                <a:cubicBezTo>
-                  <a:pt x="25587" y="209550"/>
-                  <a:pt x="0" y="183963"/>
-                  <a:pt x="0" y="152400"/>
-                </a:cubicBezTo>
-                <a:lnTo>
-                  <a:pt x="0" y="57150"/>
-                </a:lnTo>
-                <a:cubicBezTo>
-                  <a:pt x="0" y="25587"/>
-                  <a:pt x="25587" y="0"/>
-                  <a:pt x="57150" y="0"/>
-                </a:cubicBezTo>
-                <a:close/>
-              </a:path>
-            </a:pathLst>
-          </a:custGeom>
-          <a:solidFill>
-            <a:srgbClr val="FFD100"/>
-          </a:solidFill>
-          <a:ln>
-            <a:noFill/>
-          </a:ln>
-        </p:spPr>
-      </p:sp>
-      <p:sp>
-        <p:nvSpPr>
-          <p:cNvPr id="5" name="TextBox 5"/>
-          <p:cNvSpPr txBox="1"/>
-          <p:nvPr/>
-        </p:nvSpPr>
-        <p:spPr>
-          <a:xfrm>
-            <a:off x="863363" y="340995"/>
-            <a:ext cx="140175" cy="182880"/>
-          </a:xfrm>
-          <a:prstGeom prst="rect">
-            <a:avLst/>
-          </a:prstGeom>
-          <a:noFill/>
-          <a:ln>
-            <a:noFill/>
-          </a:ln>
-        </p:spPr>
-        <p:txBody>
-          <a:bodyPr wrap="none" lIns="0" tIns="0" rIns="0" bIns="0" anchor="t" anchorCtr="0">
-            <a:spAutoFit/>
-          </a:bodyPr>
-          <a:lstStyle/>
-          <a:p>
-            <a:pPr algn="ctr"/>
-            <a:r>
-              <a:rPr lang="zh-CN" sz="900" b="1" dirty="0">
-                <a:solidFill>
-                  <a:srgbClr val="000000"/>
-                </a:solidFill>
-                <a:latin typeface="Arial"/>
-                <a:ea typeface="Microsoft YaHei"/>
-                <a:cs typeface="Arial"/>
-              </a:rPr>
-              <a:t>15</a:t>
-            </a:r>
-          </a:p>
-        </p:txBody>
-      </p:sp>
-      <p:sp>
-        <p:nvSpPr>
-          <p:cNvPr id="6" name="TextBox 6"/>
-          <p:cNvSpPr txBox="1"/>
-          <p:nvPr/>
-        </p:nvSpPr>
-        <p:spPr>
-          <a:xfrm>
-            <a:off x="1188720" y="340995"/>
-            <a:ext cx="811530" cy="182880"/>
-          </a:xfrm>
-          <a:prstGeom prst="rect">
-            <a:avLst/>
-          </a:prstGeom>
-          <a:noFill/>
-          <a:ln>
-            <a:noFill/>
-          </a:ln>
-        </p:spPr>
-        <p:txBody>
-          <a:bodyPr wrap="none" lIns="0" tIns="0" rIns="0" bIns="0" anchor="t" anchorCtr="0">
-            <a:spAutoFit/>
-          </a:bodyPr>
-          <a:lstStyle/>
-          <a:p>
-            <a:pPr algn="l"/>
-            <a:r>
-              <a:rPr lang="zh-CN" sz="900" dirty="0">
-                <a:solidFill>
-                  <a:srgbClr val="999999"/>
-                </a:solidFill>
-                <a:latin typeface="Arial"/>
-                <a:ea typeface="Microsoft YaHei"/>
-                <a:cs typeface="Arial"/>
-              </a:rPr>
-              <a:t>品牌原生流派</a:t>
-            </a:r>
-          </a:p>
-        </p:txBody>
-      </p:sp>
-      <p:sp>
-        <p:nvSpPr>
-          <p:cNvPr id="7" name="TextBox 7"/>
-          <p:cNvSpPr txBox="1"/>
-          <p:nvPr/>
-        </p:nvSpPr>
-        <p:spPr>
-          <a:xfrm>
-            <a:off x="725805" y="692468"/>
-            <a:ext cx="3984029" cy="579120"/>
-          </a:xfrm>
-          <a:prstGeom prst="rect">
-            <a:avLst/>
-          </a:prstGeom>
-          <a:noFill/>
-          <a:ln>
-            <a:noFill/>
-          </a:ln>
-        </p:spPr>
-        <p:txBody>
-          <a:bodyPr wrap="none" lIns="0" tIns="0" rIns="0" bIns="0" anchor="t" anchorCtr="0">
-            <a:spAutoFit/>
-          </a:bodyPr>
-          <a:lstStyle/>
-          <a:p>
-            <a:pPr algn="l"/>
-            <a:r>
-              <a:rPr lang="zh-CN" sz="2850" b="1" dirty="0">
-                <a:solidFill>
-                  <a:srgbClr val="000000"/>
-                </a:solidFill>
-                <a:latin typeface="Arial"/>
-                <a:ea typeface="Microsoft YaHei"/>
-                <a:cs typeface="Arial"/>
-              </a:rPr>
-              <a:t>Meituan · 阳光活力</a:t>
-            </a:r>
-          </a:p>
-        </p:txBody>
-      </p:sp>
-      <p:sp>
-        <p:nvSpPr>
-          <p:cNvPr id="8" name="Rectangle 8"/>
-          <p:cNvSpPr/>
-          <p:nvPr/>
-        </p:nvSpPr>
-        <p:spPr>
-          <a:xfrm>
-            <a:off x="762000" y="1143000"/>
-            <a:ext cx="762000" cy="28575"/>
-          </a:xfrm>
-          <a:prstGeom prst="rect">
-            <a:avLst/>
-          </a:prstGeom>
-          <a:solidFill>
-            <a:srgbClr val="FFD100"/>
-          </a:solidFill>
-          <a:ln>
-            <a:noFill/>
-          </a:ln>
-        </p:spPr>
-      </p:sp>
-      <p:sp>
-        <p:nvSpPr>
-          <p:cNvPr id="9" name="TextBox 9"/>
-          <p:cNvSpPr txBox="1"/>
-          <p:nvPr/>
-        </p:nvSpPr>
-        <p:spPr>
-          <a:xfrm>
-            <a:off x="744855" y="1425892"/>
-            <a:ext cx="3011519" cy="274320"/>
-          </a:xfrm>
-          <a:prstGeom prst="rect">
-            <a:avLst/>
-          </a:prstGeom>
-          <a:noFill/>
-          <a:ln>
-            <a:noFill/>
-          </a:ln>
-        </p:spPr>
-        <p:txBody>
-          <a:bodyPr wrap="none" lIns="0" tIns="0" rIns="0" bIns="0" anchor="t" anchorCtr="0">
-            <a:spAutoFit/>
-          </a:bodyPr>
-          <a:lstStyle/>
-          <a:p>
-            <a:pPr algn="l"/>
-            <a:r>
-              <a:rPr lang="zh-CN" sz="1350" dirty="0">
-                <a:solidFill>
-                  <a:srgbClr val="000000">
-                    <a:alpha val="65000"/>
-                  </a:srgbClr>
-                </a:solidFill>
-                <a:latin typeface="Arial"/>
-                <a:ea typeface="Microsoft YaHei"/>
-                <a:cs typeface="Arial"/>
-              </a:rPr>
-              <a:t>"美团黄如阳光般散发温暖和自信"</a:t>
-            </a:r>
-          </a:p>
-        </p:txBody>
-      </p:sp>
-      <p:sp>
-        <p:nvSpPr>
-          <p:cNvPr id="10" name="Freeform 10"/>
-          <p:cNvSpPr/>
-          <p:nvPr/>
-        </p:nvSpPr>
-        <p:spPr>
-          <a:xfrm>
-            <a:off x="762000" y="1809750"/>
-            <a:ext cx="1047750" cy="285750"/>
-          </a:xfrm>
-          <a:custGeom>
-            <a:avLst/>
-            <a:gdLst/>
-            <a:ahLst/>
-            <a:cxnLst/>
-            <a:rect l="l" t="t" r="r" b="b"/>
-            <a:pathLst>
-              <a:path w="1047750" h="285750">
-                <a:moveTo>
-                  <a:pt x="76200" y="0"/>
-                </a:moveTo>
-                <a:lnTo>
-                  <a:pt x="971550" y="0"/>
-                </a:lnTo>
-                <a:cubicBezTo>
-                  <a:pt x="1013634" y="0"/>
-                  <a:pt x="1047750" y="34116"/>
-                  <a:pt x="1047750" y="76200"/>
-                </a:cubicBezTo>
-                <a:lnTo>
-                  <a:pt x="1047750" y="209550"/>
-                </a:lnTo>
-                <a:cubicBezTo>
-                  <a:pt x="1047750" y="251634"/>
-                  <a:pt x="1013634" y="285750"/>
-                  <a:pt x="971550" y="285750"/>
-                </a:cubicBezTo>
-                <a:lnTo>
-                  <a:pt x="76200" y="285750"/>
-                </a:lnTo>
-                <a:cubicBezTo>
-                  <a:pt x="34116" y="285750"/>
-                  <a:pt x="0" y="251634"/>
-                  <a:pt x="0" y="209550"/>
-                </a:cubicBezTo>
-                <a:lnTo>
-                  <a:pt x="0" y="76200"/>
-                </a:lnTo>
-                <a:cubicBezTo>
-                  <a:pt x="0" y="34116"/>
-                  <a:pt x="34116" y="0"/>
-                  <a:pt x="76200" y="0"/>
-                </a:cubicBezTo>
-                <a:close/>
-              </a:path>
-            </a:pathLst>
-          </a:custGeom>
-          <a:solidFill>
-            <a:srgbClr val="FFD100">
-              <a:alpha val="15000"/>
-            </a:srgbClr>
-          </a:solidFill>
-          <a:ln>
-            <a:noFill/>
-          </a:ln>
-        </p:spPr>
-      </p:sp>
-      <p:sp>
-        <p:nvSpPr>
-          <p:cNvPr id="11" name="TextBox 11"/>
-          <p:cNvSpPr txBox="1"/>
-          <p:nvPr/>
-        </p:nvSpPr>
-        <p:spPr>
-          <a:xfrm>
-            <a:off x="988695" y="1894999"/>
-            <a:ext cx="594360" cy="198120"/>
-          </a:xfrm>
-          <a:prstGeom prst="rect">
-            <a:avLst/>
-          </a:prstGeom>
-          <a:noFill/>
-          <a:ln>
-            <a:noFill/>
-          </a:ln>
-        </p:spPr>
-        <p:txBody>
-          <a:bodyPr wrap="none" lIns="0" tIns="0" rIns="0" bIns="0" anchor="t" anchorCtr="0">
-            <a:spAutoFit/>
-          </a:bodyPr>
-          <a:lstStyle/>
-          <a:p>
-            <a:pPr algn="ctr"/>
-            <a:r>
-              <a:rPr lang="zh-CN" sz="975" dirty="0">
-                <a:solidFill>
-                  <a:srgbClr val="000000">
-                    <a:alpha val="70000"/>
-                  </a:srgbClr>
-                </a:solidFill>
-                <a:latin typeface="Arial"/>
-                <a:ea typeface="Microsoft YaHei"/>
-                <a:cs typeface="Arial"/>
-              </a:rPr>
-              <a:t>品牌原生</a:t>
-            </a:r>
-          </a:p>
-        </p:txBody>
-      </p:sp>
-      <p:sp>
-        <p:nvSpPr>
-          <p:cNvPr id="12" name="Freeform 12"/>
-          <p:cNvSpPr/>
-          <p:nvPr/>
-        </p:nvSpPr>
-        <p:spPr>
-          <a:xfrm>
-            <a:off x="1905000" y="1809750"/>
-            <a:ext cx="1047750" cy="285750"/>
-          </a:xfrm>
-          <a:custGeom>
-            <a:avLst/>
-            <a:gdLst/>
-            <a:ahLst/>
-            <a:cxnLst/>
-            <a:rect l="l" t="t" r="r" b="b"/>
-            <a:pathLst>
-              <a:path w="1047750" h="285750">
-                <a:moveTo>
-                  <a:pt x="76200" y="0"/>
-                </a:moveTo>
-                <a:lnTo>
-                  <a:pt x="971550" y="0"/>
-                </a:lnTo>
-                <a:cubicBezTo>
-                  <a:pt x="1013634" y="0"/>
-                  <a:pt x="1047750" y="34116"/>
-                  <a:pt x="1047750" y="76200"/>
-                </a:cubicBezTo>
-                <a:lnTo>
-                  <a:pt x="1047750" y="209550"/>
-                </a:lnTo>
-                <a:cubicBezTo>
-                  <a:pt x="1047750" y="251634"/>
-                  <a:pt x="1013634" y="285750"/>
-                  <a:pt x="971550" y="285750"/>
-                </a:cubicBezTo>
-                <a:lnTo>
-                  <a:pt x="76200" y="285750"/>
-                </a:lnTo>
-                <a:cubicBezTo>
-                  <a:pt x="34116" y="285750"/>
-                  <a:pt x="0" y="251634"/>
-                  <a:pt x="0" y="209550"/>
-                </a:cubicBezTo>
-                <a:lnTo>
-                  <a:pt x="0" y="76200"/>
-                </a:lnTo>
-                <a:cubicBezTo>
-                  <a:pt x="0" y="34116"/>
-                  <a:pt x="34116" y="0"/>
-                  <a:pt x="76200" y="0"/>
-                </a:cubicBezTo>
-                <a:close/>
-              </a:path>
-            </a:pathLst>
-          </a:custGeom>
-          <a:solidFill>
-            <a:srgbClr val="FFD100">
-              <a:alpha val="15000"/>
-            </a:srgbClr>
-          </a:solidFill>
-          <a:ln>
-            <a:noFill/>
-          </a:ln>
-        </p:spPr>
-      </p:sp>
-      <p:sp>
-        <p:nvSpPr>
-          <p:cNvPr id="13" name="TextBox 13"/>
-          <p:cNvSpPr txBox="1"/>
-          <p:nvPr/>
-        </p:nvSpPr>
-        <p:spPr>
-          <a:xfrm>
-            <a:off x="2131695" y="1894999"/>
-            <a:ext cx="594360" cy="198120"/>
-          </a:xfrm>
-          <a:prstGeom prst="rect">
-            <a:avLst/>
-          </a:prstGeom>
-          <a:noFill/>
-          <a:ln>
-            <a:noFill/>
-          </a:ln>
-        </p:spPr>
-        <p:txBody>
-          <a:bodyPr wrap="none" lIns="0" tIns="0" rIns="0" bIns="0" anchor="t" anchorCtr="0">
-            <a:spAutoFit/>
-          </a:bodyPr>
-          <a:lstStyle/>
-          <a:p>
-            <a:pPr algn="ctr"/>
-            <a:r>
-              <a:rPr lang="zh-CN" sz="975" dirty="0">
-                <a:solidFill>
-                  <a:srgbClr val="000000">
-                    <a:alpha val="70000"/>
-                  </a:srgbClr>
-                </a:solidFill>
-                <a:latin typeface="Arial"/>
-                <a:ea typeface="Microsoft YaHei"/>
-                <a:cs typeface="Arial"/>
-              </a:rPr>
-              <a:t>阳光温暖</a:t>
-            </a:r>
-          </a:p>
-        </p:txBody>
-      </p:sp>
-      <p:sp>
-        <p:nvSpPr>
-          <p:cNvPr id="14" name="Freeform 14"/>
-          <p:cNvSpPr/>
-          <p:nvPr/>
-        </p:nvSpPr>
-        <p:spPr>
-          <a:xfrm>
-            <a:off x="3048000" y="1809750"/>
-            <a:ext cx="1047750" cy="285750"/>
-          </a:xfrm>
-          <a:custGeom>
-            <a:avLst/>
-            <a:gdLst/>
-            <a:ahLst/>
-            <a:cxnLst/>
-            <a:rect l="l" t="t" r="r" b="b"/>
-            <a:pathLst>
-              <a:path w="1047750" h="285750">
-                <a:moveTo>
-                  <a:pt x="76200" y="0"/>
-                </a:moveTo>
-                <a:lnTo>
-                  <a:pt x="971550" y="0"/>
-                </a:lnTo>
-                <a:cubicBezTo>
-                  <a:pt x="1013634" y="0"/>
-                  <a:pt x="1047750" y="34116"/>
-                  <a:pt x="1047750" y="76200"/>
-                </a:cubicBezTo>
-                <a:lnTo>
-                  <a:pt x="1047750" y="209550"/>
-                </a:lnTo>
-                <a:cubicBezTo>
-                  <a:pt x="1047750" y="251634"/>
-                  <a:pt x="1013634" y="285750"/>
-                  <a:pt x="971550" y="285750"/>
-                </a:cubicBezTo>
-                <a:lnTo>
-                  <a:pt x="76200" y="285750"/>
-                </a:lnTo>
-                <a:cubicBezTo>
-                  <a:pt x="34116" y="285750"/>
-                  <a:pt x="0" y="251634"/>
-                  <a:pt x="0" y="209550"/>
-                </a:cubicBezTo>
-                <a:lnTo>
-                  <a:pt x="0" y="76200"/>
-                </a:lnTo>
-                <a:cubicBezTo>
-                  <a:pt x="0" y="34116"/>
-                  <a:pt x="34116" y="0"/>
-                  <a:pt x="76200" y="0"/>
-                </a:cubicBezTo>
-                <a:close/>
-              </a:path>
-            </a:pathLst>
-          </a:custGeom>
-          <a:solidFill>
-            <a:srgbClr val="FFD100">
-              <a:alpha val="15000"/>
-            </a:srgbClr>
-          </a:solidFill>
-          <a:ln>
-            <a:noFill/>
-          </a:ln>
-        </p:spPr>
-      </p:sp>
-      <p:sp>
-        <p:nvSpPr>
-          <p:cNvPr id="15" name="TextBox 15"/>
-          <p:cNvSpPr txBox="1"/>
-          <p:nvPr/>
-        </p:nvSpPr>
-        <p:spPr>
-          <a:xfrm>
-            <a:off x="3274695" y="1894999"/>
-            <a:ext cx="594360" cy="198120"/>
-          </a:xfrm>
-          <a:prstGeom prst="rect">
-            <a:avLst/>
-          </a:prstGeom>
-          <a:noFill/>
-          <a:ln>
-            <a:noFill/>
-          </a:ln>
-        </p:spPr>
-        <p:txBody>
-          <a:bodyPr wrap="none" lIns="0" tIns="0" rIns="0" bIns="0" anchor="t" anchorCtr="0">
-            <a:spAutoFit/>
-          </a:bodyPr>
-          <a:lstStyle/>
-          <a:p>
-            <a:pPr algn="ctr"/>
-            <a:r>
-              <a:rPr lang="zh-CN" sz="975" dirty="0">
-                <a:solidFill>
-                  <a:srgbClr val="000000">
-                    <a:alpha val="70000"/>
-                  </a:srgbClr>
-                </a:solidFill>
-                <a:latin typeface="Arial"/>
-                <a:ea typeface="Microsoft YaHei"/>
-                <a:cs typeface="Arial"/>
-              </a:rPr>
-              <a:t>圆角亲和</a:t>
-            </a:r>
-          </a:p>
-        </p:txBody>
-      </p:sp>
-      <p:sp>
-        <p:nvSpPr>
-          <p:cNvPr id="16" name="Freeform 16"/>
-          <p:cNvSpPr/>
-          <p:nvPr/>
-        </p:nvSpPr>
-        <p:spPr>
-          <a:xfrm>
-            <a:off x="4191000" y="1809750"/>
-            <a:ext cx="1047750" cy="285750"/>
-          </a:xfrm>
-          <a:custGeom>
-            <a:avLst/>
-            <a:gdLst/>
-            <a:ahLst/>
-            <a:cxnLst/>
-            <a:rect l="l" t="t" r="r" b="b"/>
-            <a:pathLst>
-              <a:path w="1047750" h="285750">
-                <a:moveTo>
-                  <a:pt x="76200" y="0"/>
-                </a:moveTo>
-                <a:lnTo>
-                  <a:pt x="971550" y="0"/>
-                </a:lnTo>
-                <a:cubicBezTo>
-                  <a:pt x="1013634" y="0"/>
-                  <a:pt x="1047750" y="34116"/>
-                  <a:pt x="1047750" y="76200"/>
-                </a:cubicBezTo>
-                <a:lnTo>
-                  <a:pt x="1047750" y="209550"/>
-                </a:lnTo>
-                <a:cubicBezTo>
-                  <a:pt x="1047750" y="251634"/>
-                  <a:pt x="1013634" y="285750"/>
-                  <a:pt x="971550" y="285750"/>
-                </a:cubicBezTo>
-                <a:lnTo>
-                  <a:pt x="76200" y="285750"/>
-                </a:lnTo>
-                <a:cubicBezTo>
-                  <a:pt x="34116" y="285750"/>
-                  <a:pt x="0" y="251634"/>
-                  <a:pt x="0" y="209550"/>
-                </a:cubicBezTo>
-                <a:lnTo>
-                  <a:pt x="0" y="76200"/>
-                </a:lnTo>
-                <a:cubicBezTo>
-                  <a:pt x="0" y="34116"/>
-                  <a:pt x="34116" y="0"/>
-                  <a:pt x="76200" y="0"/>
-                </a:cubicBezTo>
-                <a:close/>
-              </a:path>
-            </a:pathLst>
-          </a:custGeom>
-          <a:solidFill>
-            <a:srgbClr val="FFD100">
-              <a:alpha val="15000"/>
-            </a:srgbClr>
-          </a:solidFill>
-          <a:ln>
-            <a:noFill/>
-          </a:ln>
-        </p:spPr>
-      </p:sp>
-      <p:sp>
-        <p:nvSpPr>
-          <p:cNvPr id="17" name="TextBox 17"/>
-          <p:cNvSpPr txBox="1"/>
-          <p:nvPr/>
-        </p:nvSpPr>
-        <p:spPr>
-          <a:xfrm>
-            <a:off x="4417695" y="1894999"/>
-            <a:ext cx="594360" cy="198120"/>
-          </a:xfrm>
-          <a:prstGeom prst="rect">
-            <a:avLst/>
-          </a:prstGeom>
-          <a:noFill/>
-          <a:ln>
-            <a:noFill/>
-          </a:ln>
-        </p:spPr>
-        <p:txBody>
-          <a:bodyPr wrap="none" lIns="0" tIns="0" rIns="0" bIns="0" anchor="t" anchorCtr="0">
-            <a:spAutoFit/>
-          </a:bodyPr>
-          <a:lstStyle/>
-          <a:p>
-            <a:pPr algn="ctr"/>
-            <a:r>
-              <a:rPr lang="zh-CN" sz="975" dirty="0">
-                <a:solidFill>
-                  <a:srgbClr val="000000">
-                    <a:alpha val="70000"/>
-                  </a:srgbClr>
-                </a:solidFill>
-                <a:latin typeface="Arial"/>
-                <a:ea typeface="Microsoft YaHei"/>
-                <a:cs typeface="Arial"/>
-              </a:rPr>
-              <a:t>年轻乐观</a:t>
-            </a:r>
-          </a:p>
-        </p:txBody>
-      </p:sp>
-      <p:sp>
-        <p:nvSpPr>
-          <p:cNvPr id="18" name="TextBox 18"/>
-          <p:cNvSpPr txBox="1"/>
-          <p:nvPr/>
-        </p:nvSpPr>
-        <p:spPr>
-          <a:xfrm>
-            <a:off x="747712" y="2497931"/>
-            <a:ext cx="1055078" cy="228600"/>
-          </a:xfrm>
-          <a:prstGeom prst="rect">
-            <a:avLst/>
-          </a:prstGeom>
-          <a:noFill/>
-          <a:ln>
-            <a:noFill/>
-          </a:ln>
-        </p:spPr>
-        <p:txBody>
-          <a:bodyPr wrap="none" lIns="0" tIns="0" rIns="0" bIns="0" anchor="t" anchorCtr="0">
-            <a:spAutoFit/>
-          </a:bodyPr>
-          <a:lstStyle/>
-          <a:p>
-            <a:pPr algn="l"/>
-            <a:r>
-              <a:rPr lang="zh-CN" sz="1125" b="1" dirty="0">
-                <a:solidFill>
-                  <a:srgbClr val="000000"/>
-                </a:solidFill>
-                <a:latin typeface="Arial"/>
-                <a:ea typeface="Microsoft YaHei"/>
-                <a:cs typeface="Arial"/>
-              </a:rPr>
-              <a:t>SVG 转化特征</a:t>
-            </a:r>
-          </a:p>
-        </p:txBody>
-      </p:sp>
-      <p:sp>
-        <p:nvSpPr>
-          <p:cNvPr id="19" name="TextBox 19"/>
-          <p:cNvSpPr txBox="1"/>
-          <p:nvPr/>
-        </p:nvSpPr>
-        <p:spPr>
-          <a:xfrm>
-            <a:off x="748665" y="2791778"/>
-            <a:ext cx="2173605" cy="213360"/>
-          </a:xfrm>
-          <a:prstGeom prst="rect">
-            <a:avLst/>
-          </a:prstGeom>
-          <a:noFill/>
-          <a:ln>
-            <a:noFill/>
-          </a:ln>
-        </p:spPr>
-        <p:txBody>
-          <a:bodyPr wrap="none" lIns="0" tIns="0" rIns="0" bIns="0" anchor="t" anchorCtr="0">
-            <a:spAutoFit/>
-          </a:bodyPr>
-          <a:lstStyle/>
-          <a:p>
-            <a:pPr algn="l"/>
-            <a:r>
-              <a:rPr lang="zh-CN" sz="1050" dirty="0">
-                <a:solidFill>
-                  <a:srgbClr val="555555"/>
-                </a:solidFill>
-                <a:latin typeface="Arial"/>
-                <a:ea typeface="Microsoft YaHei"/>
-                <a:cs typeface="Arial"/>
-              </a:rPr>
-              <a:t>白色背景为默认，黄色少量强调</a:t>
-            </a:r>
-          </a:p>
-        </p:txBody>
-      </p:sp>
-      <p:sp>
-        <p:nvSpPr>
-          <p:cNvPr id="20" name="TextBox 20"/>
-          <p:cNvSpPr txBox="1"/>
-          <p:nvPr/>
-        </p:nvSpPr>
-        <p:spPr>
-          <a:xfrm>
-            <a:off x="748665" y="3039428"/>
-            <a:ext cx="2288619" cy="213360"/>
-          </a:xfrm>
-          <a:prstGeom prst="rect">
-            <a:avLst/>
-          </a:prstGeom>
-          <a:noFill/>
-          <a:ln>
-            <a:noFill/>
-          </a:ln>
-        </p:spPr>
-        <p:txBody>
-          <a:bodyPr wrap="none" lIns="0" tIns="0" rIns="0" bIns="0" anchor="t" anchorCtr="0">
-            <a:spAutoFit/>
-          </a:bodyPr>
-          <a:lstStyle/>
-          <a:p>
-            <a:pPr algn="l"/>
-            <a:r>
-              <a:rPr lang="zh-CN" sz="1050" dirty="0">
-                <a:solidFill>
-                  <a:srgbClr val="555555"/>
-                </a:solidFill>
-                <a:latin typeface="Arial"/>
-                <a:ea typeface="Microsoft YaHei"/>
-                <a:cs typeface="Arial"/>
-              </a:rPr>
-              <a:t>圆角矩形 rx=12-16 呼应 App 图标</a:t>
-            </a:r>
-          </a:p>
-        </p:txBody>
-      </p:sp>
-      <p:sp>
-        <p:nvSpPr>
-          <p:cNvPr id="21" name="TextBox 21"/>
-          <p:cNvSpPr txBox="1"/>
-          <p:nvPr/>
-        </p:nvSpPr>
-        <p:spPr>
-          <a:xfrm>
-            <a:off x="748665" y="3287078"/>
-            <a:ext cx="1882235" cy="213360"/>
-          </a:xfrm>
-          <a:prstGeom prst="rect">
-            <a:avLst/>
-          </a:prstGeom>
-          <a:noFill/>
-          <a:ln>
-            <a:noFill/>
-          </a:ln>
-        </p:spPr>
-        <p:txBody>
-          <a:bodyPr wrap="none" lIns="0" tIns="0" rIns="0" bIns="0" anchor="t" anchorCtr="0">
-            <a:spAutoFit/>
-          </a:bodyPr>
-          <a:lstStyle/>
-          <a:p>
-            <a:pPr algn="l"/>
-            <a:r>
-              <a:rPr lang="zh-CN" sz="1050" dirty="0">
-                <a:solidFill>
-                  <a:srgbClr val="555555"/>
-                </a:solidFill>
-                <a:latin typeface="Arial"/>
-                <a:ea typeface="Microsoft YaHei"/>
-                <a:cs typeface="Arial"/>
-              </a:rPr>
-              <a:t>品牌条 + App 图标置于底部</a:t>
-            </a:r>
-          </a:p>
-        </p:txBody>
-      </p:sp>
-      <p:sp>
-        <p:nvSpPr>
-          <p:cNvPr id="22" name="TextBox 22"/>
-          <p:cNvSpPr txBox="1"/>
-          <p:nvPr/>
-        </p:nvSpPr>
-        <p:spPr>
-          <a:xfrm>
-            <a:off x="748665" y="3534728"/>
-            <a:ext cx="1951244" cy="213360"/>
-          </a:xfrm>
-          <a:prstGeom prst="rect">
-            <a:avLst/>
-          </a:prstGeom>
-          <a:noFill/>
-          <a:ln>
-            <a:noFill/>
-          </a:ln>
-        </p:spPr>
-        <p:txBody>
-          <a:bodyPr wrap="none" lIns="0" tIns="0" rIns="0" bIns="0" anchor="t" anchorCtr="0">
-            <a:spAutoFit/>
-          </a:bodyPr>
-          <a:lstStyle/>
-          <a:p>
-            <a:pPr algn="l"/>
-            <a:r>
-              <a:rPr lang="zh-CN" sz="1050" dirty="0">
-                <a:solidFill>
-                  <a:srgbClr val="555555"/>
-                </a:solidFill>
-                <a:latin typeface="Arial"/>
-                <a:ea typeface="Microsoft YaHei"/>
-                <a:cs typeface="Arial"/>
-              </a:rPr>
-              <a:t>袋鼠耳朵可作微妙水印/分隔</a:t>
-            </a:r>
-          </a:p>
-        </p:txBody>
-      </p:sp>
-      <p:sp>
-        <p:nvSpPr>
-          <p:cNvPr id="23" name="Freeform 23"/>
-          <p:cNvSpPr/>
-          <p:nvPr/>
-        </p:nvSpPr>
-        <p:spPr>
-          <a:xfrm>
-            <a:off x="5905500" y="2381250"/>
-            <a:ext cx="5334000" cy="1905000"/>
-          </a:xfrm>
-          <a:custGeom>
-            <a:avLst/>
-            <a:gdLst/>
-            <a:ahLst/>
-            <a:cxnLst/>
-            <a:rect l="l" t="t" r="r" b="b"/>
-            <a:pathLst>
-              <a:path w="5334000" h="1905000">
-                <a:moveTo>
-                  <a:pt x="152400" y="0"/>
-                </a:moveTo>
-                <a:lnTo>
-                  <a:pt x="5181600" y="0"/>
-                </a:lnTo>
-                <a:cubicBezTo>
-                  <a:pt x="5265768" y="0"/>
-                  <a:pt x="5334000" y="68232"/>
-                  <a:pt x="5334000" y="152400"/>
-                </a:cubicBezTo>
-                <a:lnTo>
-                  <a:pt x="5334000" y="1752600"/>
-                </a:lnTo>
-                <a:cubicBezTo>
-                  <a:pt x="5334000" y="1836768"/>
-                  <a:pt x="5265768" y="1905000"/>
-                  <a:pt x="5181600" y="1905000"/>
-                </a:cubicBezTo>
-                <a:lnTo>
-                  <a:pt x="152400" y="1905000"/>
-                </a:lnTo>
-                <a:cubicBezTo>
-                  <a:pt x="68232" y="1905000"/>
-                  <a:pt x="0" y="1836768"/>
-                  <a:pt x="0" y="1752600"/>
-                </a:cubicBezTo>
-                <a:lnTo>
-                  <a:pt x="0" y="152400"/>
-                </a:lnTo>
-                <a:cubicBezTo>
-                  <a:pt x="0" y="68232"/>
-                  <a:pt x="68232" y="0"/>
-                  <a:pt x="152400" y="0"/>
-                </a:cubicBezTo>
-                <a:close/>
-              </a:path>
-            </a:pathLst>
-          </a:custGeom>
-          <a:solidFill>
-            <a:srgbClr val="FFF8E0"/>
-          </a:solidFill>
-          <a:ln>
-            <a:noFill/>
-          </a:ln>
-        </p:spPr>
-      </p:sp>
-      <p:sp>
-        <p:nvSpPr>
-          <p:cNvPr id="24" name="TextBox 24"/>
-          <p:cNvSpPr txBox="1"/>
-          <p:nvPr/>
-        </p:nvSpPr>
-        <p:spPr>
-          <a:xfrm>
-            <a:off x="6083618" y="2561749"/>
-            <a:ext cx="622840" cy="198120"/>
-          </a:xfrm>
-          <a:prstGeom prst="rect">
-            <a:avLst/>
-          </a:prstGeom>
-          <a:noFill/>
-          <a:ln>
-            <a:noFill/>
-          </a:ln>
-        </p:spPr>
-        <p:txBody>
-          <a:bodyPr wrap="none" lIns="0" tIns="0" rIns="0" bIns="0" anchor="t" anchorCtr="0">
-            <a:spAutoFit/>
-          </a:bodyPr>
-          <a:lstStyle/>
-          <a:p>
-            <a:pPr algn="l"/>
-            <a:r>
-              <a:rPr lang="zh-CN" sz="975" b="1" dirty="0">
-                <a:solidFill>
-                  <a:srgbClr val="000000">
-                    <a:alpha val="50000"/>
-                  </a:srgbClr>
-                </a:solidFill>
-                <a:latin typeface="Arial"/>
-                <a:ea typeface="Microsoft YaHei"/>
-                <a:cs typeface="Arial"/>
-              </a:rPr>
-              <a:t>品牌元素</a:t>
-            </a:r>
-          </a:p>
-        </p:txBody>
-      </p:sp>
-      <p:sp>
-        <p:nvSpPr>
-          <p:cNvPr id="25" name="Freeform 25"/>
-          <p:cNvSpPr/>
-          <p:nvPr/>
-        </p:nvSpPr>
-        <p:spPr>
-          <a:xfrm>
-            <a:off x="6286500" y="2857500"/>
-            <a:ext cx="457200" cy="457200"/>
-          </a:xfrm>
-          <a:custGeom>
-            <a:avLst/>
-            <a:gdLst/>
-            <a:ahLst/>
-            <a:cxnLst/>
-            <a:rect l="l" t="t" r="r" b="b"/>
-            <a:pathLst>
-              <a:path w="457200" h="457200">
-                <a:moveTo>
-                  <a:pt x="114300" y="0"/>
-                </a:moveTo>
-                <a:lnTo>
-                  <a:pt x="342900" y="0"/>
-                </a:lnTo>
-                <a:cubicBezTo>
-                  <a:pt x="406026" y="0"/>
-                  <a:pt x="457200" y="51174"/>
-                  <a:pt x="457200" y="114300"/>
-                </a:cubicBezTo>
-                <a:lnTo>
-                  <a:pt x="457200" y="342900"/>
-                </a:lnTo>
-                <a:cubicBezTo>
-                  <a:pt x="457200" y="406026"/>
-                  <a:pt x="406026" y="457200"/>
-                  <a:pt x="342900" y="457200"/>
-                </a:cubicBezTo>
-                <a:lnTo>
-                  <a:pt x="114300" y="457200"/>
-                </a:lnTo>
-                <a:cubicBezTo>
-                  <a:pt x="51174" y="457200"/>
-                  <a:pt x="0" y="406026"/>
-                  <a:pt x="0" y="342900"/>
-                </a:cubicBezTo>
-                <a:lnTo>
-                  <a:pt x="0" y="114300"/>
-                </a:lnTo>
-                <a:cubicBezTo>
-                  <a:pt x="0" y="51174"/>
-                  <a:pt x="51174" y="0"/>
-                  <a:pt x="114300" y="0"/>
-                </a:cubicBezTo>
-                <a:close/>
-              </a:path>
-            </a:pathLst>
-          </a:custGeom>
-          <a:solidFill>
-            <a:srgbClr val="FFD100"/>
-          </a:solidFill>
-          <a:ln>
-            <a:noFill/>
-          </a:ln>
-        </p:spPr>
-      </p:sp>
-      <p:sp>
-        <p:nvSpPr>
-          <p:cNvPr id="26" name="TextBox 26"/>
-          <p:cNvSpPr txBox="1"/>
-          <p:nvPr/>
-        </p:nvSpPr>
-        <p:spPr>
-          <a:xfrm>
-            <a:off x="6421255" y="3048952"/>
-            <a:ext cx="187690" cy="213360"/>
-          </a:xfrm>
-          <a:prstGeom prst="rect">
-            <a:avLst/>
-          </a:prstGeom>
-          <a:noFill/>
-          <a:ln>
-            <a:noFill/>
-          </a:ln>
-        </p:spPr>
-        <p:txBody>
-          <a:bodyPr wrap="none" lIns="0" tIns="0" rIns="0" bIns="0" anchor="t" anchorCtr="0">
-            <a:spAutoFit/>
-          </a:bodyPr>
-          <a:lstStyle/>
-          <a:p>
-            <a:pPr algn="ctr"/>
-            <a:r>
-              <a:rPr lang="zh-CN" sz="1050" b="1" dirty="0">
-                <a:solidFill>
-                  <a:srgbClr val="000000"/>
-                </a:solidFill>
-                <a:latin typeface="Arial"/>
-                <a:ea typeface="Microsoft YaHei"/>
-                <a:cs typeface="Arial"/>
-              </a:rPr>
-              <a:t>美</a:t>
-            </a:r>
-          </a:p>
-        </p:txBody>
-      </p:sp>
-      <p:sp>
-        <p:nvSpPr>
-          <p:cNvPr id="27" name="TextBox 27"/>
-          <p:cNvSpPr txBox="1"/>
-          <p:nvPr/>
-        </p:nvSpPr>
-        <p:spPr>
-          <a:xfrm>
-            <a:off x="6846570" y="3046095"/>
-            <a:ext cx="542068" cy="182880"/>
-          </a:xfrm>
-          <a:prstGeom prst="rect">
-            <a:avLst/>
-          </a:prstGeom>
-          <a:noFill/>
-          <a:ln>
-            <a:noFill/>
-          </a:ln>
-        </p:spPr>
-        <p:txBody>
-          <a:bodyPr wrap="none" lIns="0" tIns="0" rIns="0" bIns="0" anchor="t" anchorCtr="0">
-            <a:spAutoFit/>
-          </a:bodyPr>
-          <a:lstStyle/>
-          <a:p>
-            <a:pPr algn="l"/>
-            <a:r>
-              <a:rPr lang="zh-CN" sz="900" dirty="0">
-                <a:solidFill>
-                  <a:srgbClr val="666666"/>
-                </a:solidFill>
-                <a:latin typeface="Arial"/>
-                <a:ea typeface="Microsoft YaHei"/>
-                <a:cs typeface="Arial"/>
-              </a:rPr>
-              <a:t>App 图标</a:t>
-            </a:r>
-          </a:p>
-        </p:txBody>
-      </p:sp>
-      <p:sp>
-        <p:nvSpPr>
-          <p:cNvPr id="28" name="Freeform 28"/>
-          <p:cNvSpPr/>
-          <p:nvPr/>
-        </p:nvSpPr>
-        <p:spPr>
-          <a:xfrm>
-            <a:off x="6286500" y="3429000"/>
-            <a:ext cx="285750" cy="190500"/>
-          </a:xfrm>
-          <a:custGeom>
-            <a:avLst/>
-            <a:gdLst/>
-            <a:ahLst/>
-            <a:cxnLst/>
-            <a:rect l="l" t="t" r="r" b="b"/>
-            <a:pathLst>
-              <a:path w="285750" h="190500">
-                <a:moveTo>
-                  <a:pt x="0" y="190500"/>
-                </a:moveTo>
-                <a:cubicBezTo>
-                  <a:pt x="95250" y="0"/>
-                  <a:pt x="190500" y="0"/>
-                  <a:pt x="285750" y="190500"/>
-                </a:cubicBezTo>
-              </a:path>
-            </a:pathLst>
-          </a:custGeom>
-          <a:noFill/>
-          <a:ln w="23812">
-            <a:solidFill>
-              <a:srgbClr val="FFD100"/>
-            </a:solidFill>
-          </a:ln>
-        </p:spPr>
-      </p:sp>
-      <p:sp>
-        <p:nvSpPr>
-          <p:cNvPr id="29" name="Freeform 29"/>
-          <p:cNvSpPr/>
-          <p:nvPr/>
-        </p:nvSpPr>
-        <p:spPr>
-          <a:xfrm>
-            <a:off x="6667500" y="3429000"/>
-            <a:ext cx="285750" cy="190500"/>
-          </a:xfrm>
-          <a:custGeom>
-            <a:avLst/>
-            <a:gdLst/>
-            <a:ahLst/>
-            <a:cxnLst/>
-            <a:rect l="l" t="t" r="r" b="b"/>
-            <a:pathLst>
-              <a:path w="285750" h="190500">
-                <a:moveTo>
-                  <a:pt x="0" y="190500"/>
-                </a:moveTo>
-                <a:cubicBezTo>
-                  <a:pt x="95250" y="0"/>
-                  <a:pt x="190500" y="0"/>
-                  <a:pt x="285750" y="190500"/>
-                </a:cubicBezTo>
-              </a:path>
-            </a:pathLst>
-          </a:custGeom>
-          <a:noFill/>
-          <a:ln w="23812">
-            <a:solidFill>
-              <a:srgbClr val="FFD100"/>
-            </a:solidFill>
-          </a:ln>
-        </p:spPr>
-      </p:sp>
-      <p:sp>
-        <p:nvSpPr>
-          <p:cNvPr id="30" name="TextBox 30"/>
-          <p:cNvSpPr txBox="1"/>
-          <p:nvPr/>
-        </p:nvSpPr>
-        <p:spPr>
-          <a:xfrm>
-            <a:off x="7132320" y="3522345"/>
-            <a:ext cx="548640" cy="182880"/>
-          </a:xfrm>
-          <a:prstGeom prst="rect">
-            <a:avLst/>
-          </a:prstGeom>
-          <a:noFill/>
-          <a:ln>
-            <a:noFill/>
-          </a:ln>
-        </p:spPr>
-        <p:txBody>
-          <a:bodyPr wrap="none" lIns="0" tIns="0" rIns="0" bIns="0" anchor="t" anchorCtr="0">
-            <a:spAutoFit/>
-          </a:bodyPr>
-          <a:lstStyle/>
-          <a:p>
-            <a:pPr algn="l"/>
-            <a:r>
-              <a:rPr lang="zh-CN" sz="900" dirty="0">
-                <a:solidFill>
-                  <a:srgbClr val="666666"/>
-                </a:solidFill>
-                <a:latin typeface="Arial"/>
-                <a:ea typeface="Microsoft YaHei"/>
-                <a:cs typeface="Arial"/>
-              </a:rPr>
-              <a:t>袋鼠耳朵</a:t>
-            </a:r>
-          </a:p>
-        </p:txBody>
-      </p:sp>
-      <p:sp>
-        <p:nvSpPr>
-          <p:cNvPr id="31" name="TextBox 31"/>
-          <p:cNvSpPr txBox="1"/>
-          <p:nvPr/>
-        </p:nvSpPr>
-        <p:spPr>
-          <a:xfrm>
-            <a:off x="6276022" y="3959066"/>
-            <a:ext cx="1701808" cy="167640"/>
-          </a:xfrm>
-          <a:prstGeom prst="rect">
-            <a:avLst/>
-          </a:prstGeom>
-          <a:noFill/>
-          <a:ln>
-            <a:noFill/>
-          </a:ln>
-        </p:spPr>
-        <p:txBody>
-          <a:bodyPr wrap="none" lIns="0" tIns="0" rIns="0" bIns="0" anchor="t" anchorCtr="0">
-            <a:spAutoFit/>
-          </a:bodyPr>
-          <a:lstStyle/>
-          <a:p>
-            <a:pPr algn="l"/>
-            <a:r>
-              <a:rPr lang="zh-CN" sz="825" dirty="0">
-                <a:solidFill>
-                  <a:srgbClr val="C41E3A">
-                    <a:alpha val="60000"/>
-                  </a:srgbClr>
-                </a:solidFill>
-                <a:latin typeface="Arial"/>
-                <a:ea typeface="Microsoft YaHei"/>
-                <a:cs typeface="Arial"/>
-              </a:rPr>
-              <a:t>⚠ 禁止：白底黄字 / 黄底白logo</a:t>
-            </a:r>
-          </a:p>
-        </p:txBody>
-      </p:sp>
-      <p:sp>
-        <p:nvSpPr>
-          <p:cNvPr id="32" name="TextBox 32"/>
-          <p:cNvSpPr txBox="1"/>
-          <p:nvPr/>
-        </p:nvSpPr>
-        <p:spPr>
-          <a:xfrm>
-            <a:off x="8560118" y="2752249"/>
-            <a:ext cx="772358" cy="198120"/>
-          </a:xfrm>
-          <a:prstGeom prst="rect">
-            <a:avLst/>
-          </a:prstGeom>
-          <a:noFill/>
-          <a:ln>
-            <a:noFill/>
-          </a:ln>
-        </p:spPr>
-        <p:txBody>
-          <a:bodyPr wrap="none" lIns="0" tIns="0" rIns="0" bIns="0" anchor="t" anchorCtr="0">
-            <a:spAutoFit/>
-          </a:bodyPr>
-          <a:lstStyle/>
-          <a:p>
-            <a:pPr algn="l"/>
-            <a:r>
-              <a:rPr lang="zh-CN" sz="975" b="1" dirty="0">
-                <a:solidFill>
-                  <a:srgbClr val="000000">
-                    <a:alpha val="50000"/>
-                  </a:srgbClr>
-                </a:solidFill>
-                <a:latin typeface="Arial"/>
-                <a:ea typeface="Microsoft YaHei"/>
-                <a:cs typeface="Arial"/>
-              </a:rPr>
-              <a:t>美团体特征</a:t>
-            </a:r>
-          </a:p>
-        </p:txBody>
-      </p:sp>
-      <p:sp>
-        <p:nvSpPr>
-          <p:cNvPr id="33" name="TextBox 33"/>
-          <p:cNvSpPr txBox="1"/>
-          <p:nvPr/>
-        </p:nvSpPr>
-        <p:spPr>
-          <a:xfrm>
-            <a:off x="8561070" y="2998470"/>
-            <a:ext cx="1094137" cy="182880"/>
-          </a:xfrm>
-          <a:prstGeom prst="rect">
-            <a:avLst/>
-          </a:prstGeom>
-          <a:noFill/>
-          <a:ln>
-            <a:noFill/>
-          </a:ln>
-        </p:spPr>
-        <p:txBody>
-          <a:bodyPr wrap="none" lIns="0" tIns="0" rIns="0" bIns="0" anchor="t" anchorCtr="0">
-            <a:spAutoFit/>
-          </a:bodyPr>
-          <a:lstStyle/>
-          <a:p>
-            <a:pPr algn="l"/>
-            <a:r>
-              <a:rPr lang="zh-CN" sz="900" dirty="0">
-                <a:solidFill>
-                  <a:srgbClr val="666666"/>
-                </a:solidFill>
-                <a:latin typeface="Arial"/>
-                <a:ea typeface="Microsoft YaHei"/>
-                <a:cs typeface="Arial"/>
-              </a:rPr>
-              <a:t>撇捺斜切 → 前进感</a:t>
-            </a:r>
-          </a:p>
-        </p:txBody>
-      </p:sp>
-      <p:sp>
-        <p:nvSpPr>
-          <p:cNvPr id="34" name="TextBox 34"/>
-          <p:cNvSpPr txBox="1"/>
-          <p:nvPr/>
-        </p:nvSpPr>
-        <p:spPr>
-          <a:xfrm>
-            <a:off x="8561070" y="3236595"/>
-            <a:ext cx="1094137" cy="182880"/>
-          </a:xfrm>
-          <a:prstGeom prst="rect">
-            <a:avLst/>
-          </a:prstGeom>
-          <a:noFill/>
-          <a:ln>
-            <a:noFill/>
-          </a:ln>
-        </p:spPr>
-        <p:txBody>
-          <a:bodyPr wrap="none" lIns="0" tIns="0" rIns="0" bIns="0" anchor="t" anchorCtr="0">
-            <a:spAutoFit/>
-          </a:bodyPr>
-          <a:lstStyle/>
-          <a:p>
-            <a:pPr algn="l"/>
-            <a:r>
-              <a:rPr lang="zh-CN" sz="900" dirty="0">
-                <a:solidFill>
-                  <a:srgbClr val="666666"/>
-                </a:solidFill>
-                <a:latin typeface="Arial"/>
-                <a:ea typeface="Microsoft YaHei"/>
-                <a:cs typeface="Arial"/>
-              </a:rPr>
-              <a:t>对称圆角 → 亲和力</a:t>
-            </a:r>
-          </a:p>
-        </p:txBody>
-      </p:sp>
-      <p:sp>
-        <p:nvSpPr>
-          <p:cNvPr id="35" name="TextBox 35"/>
-          <p:cNvSpPr txBox="1"/>
-          <p:nvPr/>
-        </p:nvSpPr>
-        <p:spPr>
-          <a:xfrm>
-            <a:off x="8561070" y="3474720"/>
-            <a:ext cx="1094137" cy="182880"/>
-          </a:xfrm>
-          <a:prstGeom prst="rect">
-            <a:avLst/>
-          </a:prstGeom>
-          <a:noFill/>
-          <a:ln>
-            <a:noFill/>
-          </a:ln>
-        </p:spPr>
-        <p:txBody>
-          <a:bodyPr wrap="none" lIns="0" tIns="0" rIns="0" bIns="0" anchor="t" anchorCtr="0">
-            <a:spAutoFit/>
-          </a:bodyPr>
-          <a:lstStyle/>
-          <a:p>
-            <a:pPr algn="l"/>
-            <a:r>
-              <a:rPr lang="zh-CN" sz="900" dirty="0">
-                <a:solidFill>
-                  <a:srgbClr val="666666"/>
-                </a:solidFill>
-                <a:latin typeface="Arial"/>
-                <a:ea typeface="Microsoft YaHei"/>
-                <a:cs typeface="Arial"/>
-              </a:rPr>
-              <a:t>重心提高 → 年轻感</a:t>
-            </a:r>
-          </a:p>
-        </p:txBody>
-      </p:sp>
-      <p:sp>
-        <p:nvSpPr>
-          <p:cNvPr id="36" name="TextBox 36"/>
-          <p:cNvSpPr txBox="1"/>
-          <p:nvPr/>
-        </p:nvSpPr>
-        <p:spPr>
-          <a:xfrm>
-            <a:off x="747712" y="4450556"/>
-            <a:ext cx="1055078" cy="228600"/>
-          </a:xfrm>
-          <a:prstGeom prst="rect">
-            <a:avLst/>
-          </a:prstGeom>
-          <a:noFill/>
-          <a:ln>
-            <a:noFill/>
-          </a:ln>
-        </p:spPr>
-        <p:txBody>
-          <a:bodyPr wrap="none" lIns="0" tIns="0" rIns="0" bIns="0" anchor="t" anchorCtr="0">
-            <a:spAutoFit/>
-          </a:bodyPr>
-          <a:lstStyle/>
-          <a:p>
-            <a:pPr algn="l"/>
-            <a:r>
-              <a:rPr lang="zh-CN" sz="1125" b="1" dirty="0">
-                <a:solidFill>
-                  <a:srgbClr val="000000"/>
-                </a:solidFill>
-                <a:latin typeface="Arial"/>
-                <a:ea typeface="Microsoft YaHei"/>
-                <a:cs typeface="Arial"/>
-              </a:rPr>
-              <a:t>PPT 最佳用途</a:t>
-            </a:r>
-          </a:p>
-        </p:txBody>
-      </p:sp>
-      <p:sp>
-        <p:nvSpPr>
-          <p:cNvPr id="37" name="TextBox 37"/>
-          <p:cNvSpPr txBox="1"/>
-          <p:nvPr/>
-        </p:nvSpPr>
-        <p:spPr>
-          <a:xfrm>
-            <a:off x="748665" y="4744402"/>
-            <a:ext cx="3776139" cy="213360"/>
-          </a:xfrm>
-          <a:prstGeom prst="rect">
-            <a:avLst/>
-          </a:prstGeom>
-          <a:noFill/>
-          <a:ln>
-            <a:noFill/>
-          </a:ln>
-        </p:spPr>
-        <p:txBody>
-          <a:bodyPr wrap="none" lIns="0" tIns="0" rIns="0" bIns="0" anchor="t" anchorCtr="0">
-            <a:spAutoFit/>
-          </a:bodyPr>
-          <a:lstStyle/>
-          <a:p>
-            <a:pPr algn="l"/>
-            <a:r>
-              <a:rPr lang="zh-CN" sz="1050" dirty="0">
-                <a:solidFill>
-                  <a:srgbClr val="555555"/>
-                </a:solidFill>
-                <a:latin typeface="Arial"/>
-                <a:ea typeface="Microsoft YaHei"/>
-                <a:cs typeface="Arial"/>
-              </a:rPr>
-              <a:t>美团内部演示 · 业务复盘 · 团队会议 · 合作伙伴幻灯片</a:t>
-            </a:r>
-          </a:p>
-        </p:txBody>
-      </p:sp>
-      <p:sp>
-        <p:nvSpPr>
-          <p:cNvPr id="38" name="TextBox 38"/>
-          <p:cNvSpPr txBox="1"/>
-          <p:nvPr/>
-        </p:nvSpPr>
-        <p:spPr>
-          <a:xfrm>
-            <a:off x="747712" y="5212556"/>
-            <a:ext cx="718661" cy="228600"/>
-          </a:xfrm>
-          <a:prstGeom prst="rect">
-            <a:avLst/>
-          </a:prstGeom>
-          <a:noFill/>
-          <a:ln>
-            <a:noFill/>
-          </a:ln>
-        </p:spPr>
-        <p:txBody>
-          <a:bodyPr wrap="none" lIns="0" tIns="0" rIns="0" bIns="0" anchor="t" anchorCtr="0">
-            <a:spAutoFit/>
-          </a:bodyPr>
-          <a:lstStyle/>
-          <a:p>
-            <a:pPr algn="l"/>
-            <a:r>
-              <a:rPr lang="zh-CN" sz="1125" b="1" dirty="0">
-                <a:solidFill>
-                  <a:srgbClr val="000000"/>
-                </a:solidFill>
-                <a:latin typeface="Arial"/>
-                <a:ea typeface="Microsoft YaHei"/>
-                <a:cs typeface="Arial"/>
-              </a:rPr>
-              <a:t>色彩策略</a:t>
-            </a:r>
-          </a:p>
-        </p:txBody>
-      </p:sp>
-      <p:sp>
-        <p:nvSpPr>
-          <p:cNvPr id="39" name="TextBox 39"/>
-          <p:cNvSpPr txBox="1"/>
-          <p:nvPr/>
-        </p:nvSpPr>
-        <p:spPr>
-          <a:xfrm>
-            <a:off x="748665" y="5487352"/>
-            <a:ext cx="1429845" cy="213360"/>
-          </a:xfrm>
-          <a:prstGeom prst="rect">
-            <a:avLst/>
-          </a:prstGeom>
-          <a:noFill/>
-          <a:ln>
-            <a:noFill/>
-          </a:ln>
-        </p:spPr>
-        <p:txBody>
-          <a:bodyPr wrap="none" lIns="0" tIns="0" rIns="0" bIns="0" anchor="t" anchorCtr="0">
-            <a:spAutoFit/>
-          </a:bodyPr>
-          <a:lstStyle/>
-          <a:p>
-            <a:pPr algn="l"/>
-            <a:r>
-              <a:rPr lang="zh-CN" sz="1050" dirty="0">
-                <a:solidFill>
-                  <a:srgbClr val="666666"/>
-                </a:solidFill>
-                <a:latin typeface="Arial"/>
-                <a:ea typeface="Microsoft YaHei"/>
-                <a:cs typeface="Arial"/>
-              </a:rPr>
-              <a:t>白色为主 + 黄色事件</a:t>
-            </a:r>
-          </a:p>
-        </p:txBody>
-      </p:sp>
-      <p:sp>
-        <p:nvSpPr>
-          <p:cNvPr id="40" name="Freeform 40"/>
-          <p:cNvSpPr/>
-          <p:nvPr/>
-        </p:nvSpPr>
-        <p:spPr>
-          <a:xfrm>
-            <a:off x="762000" y="5762625"/>
-            <a:ext cx="266700" cy="266700"/>
-          </a:xfrm>
-          <a:custGeom>
-            <a:avLst/>
-            <a:gdLst/>
-            <a:ahLst/>
-            <a:cxnLst/>
-            <a:rect l="l" t="t" r="r" b="b"/>
-            <a:pathLst>
-              <a:path w="266700" h="266700">
-                <a:moveTo>
-                  <a:pt x="57150" y="0"/>
-                </a:moveTo>
-                <a:lnTo>
-                  <a:pt x="209550" y="0"/>
-                </a:lnTo>
-                <a:cubicBezTo>
-                  <a:pt x="241113" y="0"/>
-                  <a:pt x="266700" y="25587"/>
-                  <a:pt x="266700" y="57150"/>
-                </a:cubicBezTo>
-                <a:lnTo>
-                  <a:pt x="266700" y="209550"/>
-                </a:lnTo>
-                <a:cubicBezTo>
-                  <a:pt x="266700" y="241113"/>
-                  <a:pt x="241113" y="266700"/>
-                  <a:pt x="209550" y="266700"/>
-                </a:cubicBezTo>
-                <a:lnTo>
-                  <a:pt x="57150" y="266700"/>
-                </a:lnTo>
-                <a:cubicBezTo>
-                  <a:pt x="25587" y="266700"/>
-                  <a:pt x="0" y="241113"/>
-                  <a:pt x="0" y="209550"/>
-                </a:cubicBezTo>
-                <a:lnTo>
-                  <a:pt x="0" y="57150"/>
-                </a:lnTo>
-                <a:cubicBezTo>
-                  <a:pt x="0" y="25587"/>
-                  <a:pt x="25587" y="0"/>
-                  <a:pt x="57150" y="0"/>
-                </a:cubicBezTo>
-                <a:close/>
-              </a:path>
-            </a:pathLst>
-          </a:custGeom>
-          <a:solidFill>
-            <a:srgbClr val="FFFFFF"/>
-          </a:solidFill>
-          <a:ln w="9525">
-            <a:solidFill>
-              <a:srgbClr val="E0E0E0"/>
-            </a:solidFill>
-          </a:ln>
-        </p:spPr>
-      </p:sp>
-      <p:sp>
-        <p:nvSpPr>
-          <p:cNvPr id="41" name="Freeform 41"/>
-          <p:cNvSpPr/>
-          <p:nvPr/>
-        </p:nvSpPr>
-        <p:spPr>
-          <a:xfrm>
-            <a:off x="1123950" y="5762625"/>
-            <a:ext cx="266700" cy="266700"/>
-          </a:xfrm>
-          <a:custGeom>
-            <a:avLst/>
-            <a:gdLst/>
-            <a:ahLst/>
-            <a:cxnLst/>
-            <a:rect l="l" t="t" r="r" b="b"/>
-            <a:pathLst>
-              <a:path w="266700" h="266700">
-                <a:moveTo>
-                  <a:pt x="57150" y="0"/>
-                </a:moveTo>
-                <a:lnTo>
-                  <a:pt x="209550" y="0"/>
-                </a:lnTo>
-                <a:cubicBezTo>
-                  <a:pt x="241113" y="0"/>
-                  <a:pt x="266700" y="25587"/>
-                  <a:pt x="266700" y="57150"/>
-                </a:cubicBezTo>
-                <a:lnTo>
-                  <a:pt x="266700" y="209550"/>
-                </a:lnTo>
-                <a:cubicBezTo>
-                  <a:pt x="266700" y="241113"/>
-                  <a:pt x="241113" y="266700"/>
-                  <a:pt x="209550" y="266700"/>
-                </a:cubicBezTo>
-                <a:lnTo>
-                  <a:pt x="57150" y="266700"/>
-                </a:lnTo>
-                <a:cubicBezTo>
-                  <a:pt x="25587" y="266700"/>
-                  <a:pt x="0" y="241113"/>
-                  <a:pt x="0" y="209550"/>
-                </a:cubicBezTo>
-                <a:lnTo>
-                  <a:pt x="0" y="57150"/>
-                </a:lnTo>
-                <a:cubicBezTo>
-                  <a:pt x="0" y="25587"/>
-                  <a:pt x="25587" y="0"/>
-                  <a:pt x="57150" y="0"/>
-                </a:cubicBezTo>
-                <a:close/>
-              </a:path>
-            </a:pathLst>
-          </a:custGeom>
-          <a:solidFill>
-            <a:srgbClr val="FFD100"/>
-          </a:solidFill>
-          <a:ln>
-            <a:noFill/>
-          </a:ln>
-        </p:spPr>
-      </p:sp>
-      <p:sp>
-        <p:nvSpPr>
-          <p:cNvPr id="42" name="Freeform 42"/>
-          <p:cNvSpPr/>
-          <p:nvPr/>
-        </p:nvSpPr>
-        <p:spPr>
-          <a:xfrm>
-            <a:off x="1485900" y="5762625"/>
-            <a:ext cx="266700" cy="266700"/>
-          </a:xfrm>
-          <a:custGeom>
-            <a:avLst/>
-            <a:gdLst/>
-            <a:ahLst/>
-            <a:cxnLst/>
-            <a:rect l="l" t="t" r="r" b="b"/>
-            <a:pathLst>
-              <a:path w="266700" h="266700">
-                <a:moveTo>
-                  <a:pt x="57150" y="0"/>
-                </a:moveTo>
-                <a:lnTo>
-                  <a:pt x="209550" y="0"/>
-                </a:lnTo>
-                <a:cubicBezTo>
-                  <a:pt x="241113" y="0"/>
-                  <a:pt x="266700" y="25587"/>
-                  <a:pt x="266700" y="57150"/>
-                </a:cubicBezTo>
-                <a:lnTo>
-                  <a:pt x="266700" y="209550"/>
-                </a:lnTo>
-                <a:cubicBezTo>
-                  <a:pt x="266700" y="241113"/>
-                  <a:pt x="241113" y="266700"/>
-                  <a:pt x="209550" y="266700"/>
-                </a:cubicBezTo>
-                <a:lnTo>
-                  <a:pt x="57150" y="266700"/>
-                </a:lnTo>
-                <a:cubicBezTo>
-                  <a:pt x="25587" y="266700"/>
-                  <a:pt x="0" y="241113"/>
-                  <a:pt x="0" y="209550"/>
-                </a:cubicBezTo>
-                <a:lnTo>
-                  <a:pt x="0" y="57150"/>
-                </a:lnTo>
-                <a:cubicBezTo>
-                  <a:pt x="0" y="25587"/>
-                  <a:pt x="25587" y="0"/>
-                  <a:pt x="57150" y="0"/>
-                </a:cubicBezTo>
-                <a:close/>
-              </a:path>
-            </a:pathLst>
-          </a:custGeom>
-          <a:solidFill>
-            <a:srgbClr val="000000"/>
-          </a:solidFill>
-          <a:ln>
-            <a:noFill/>
-          </a:ln>
-        </p:spPr>
-      </p:sp>
-      <p:sp>
-        <p:nvSpPr>
-          <p:cNvPr id="43" name="Freeform 43"/>
-          <p:cNvSpPr/>
-          <p:nvPr/>
-        </p:nvSpPr>
-        <p:spPr>
-          <a:xfrm>
-            <a:off x="1847850" y="5762625"/>
-            <a:ext cx="266700" cy="266700"/>
-          </a:xfrm>
-          <a:custGeom>
-            <a:avLst/>
-            <a:gdLst/>
-            <a:ahLst/>
-            <a:cxnLst/>
-            <a:rect l="l" t="t" r="r" b="b"/>
-            <a:pathLst>
-              <a:path w="266700" h="266700">
-                <a:moveTo>
-                  <a:pt x="57150" y="0"/>
-                </a:moveTo>
-                <a:lnTo>
-                  <a:pt x="209550" y="0"/>
-                </a:lnTo>
-                <a:cubicBezTo>
-                  <a:pt x="241113" y="0"/>
-                  <a:pt x="266700" y="25587"/>
-                  <a:pt x="266700" y="57150"/>
-                </a:cubicBezTo>
-                <a:lnTo>
-                  <a:pt x="266700" y="209550"/>
-                </a:lnTo>
-                <a:cubicBezTo>
-                  <a:pt x="266700" y="241113"/>
-                  <a:pt x="241113" y="266700"/>
-                  <a:pt x="209550" y="266700"/>
-                </a:cubicBezTo>
-                <a:lnTo>
-                  <a:pt x="57150" y="266700"/>
-                </a:lnTo>
-                <a:cubicBezTo>
-                  <a:pt x="25587" y="266700"/>
-                  <a:pt x="0" y="241113"/>
-                  <a:pt x="0" y="209550"/>
-                </a:cubicBezTo>
-                <a:lnTo>
-                  <a:pt x="0" y="57150"/>
-                </a:lnTo>
-                <a:cubicBezTo>
-                  <a:pt x="0" y="25587"/>
-                  <a:pt x="25587" y="0"/>
-                  <a:pt x="57150" y="0"/>
-                </a:cubicBezTo>
-                <a:close/>
-              </a:path>
-            </a:pathLst>
-          </a:custGeom>
-          <a:solidFill>
-            <a:srgbClr val="666666"/>
-          </a:solidFill>
-          <a:ln>
-            <a:noFill/>
-          </a:ln>
-        </p:spPr>
-      </p:sp>
-      <p:sp>
-        <p:nvSpPr>
-          <p:cNvPr id="44" name="TextBox 44"/>
-          <p:cNvSpPr txBox="1"/>
-          <p:nvPr/>
-        </p:nvSpPr>
-        <p:spPr>
-          <a:xfrm>
-            <a:off x="5892165" y="4458652"/>
-            <a:ext cx="486727" cy="213360"/>
-          </a:xfrm>
-          <a:prstGeom prst="rect">
-            <a:avLst/>
-          </a:prstGeom>
-          <a:noFill/>
-          <a:ln>
-            <a:noFill/>
-          </a:ln>
-        </p:spPr>
-        <p:txBody>
-          <a:bodyPr wrap="none" lIns="0" tIns="0" rIns="0" bIns="0" anchor="t" anchorCtr="0">
-            <a:spAutoFit/>
-          </a:bodyPr>
-          <a:lstStyle/>
-          <a:p>
-            <a:pPr algn="l"/>
-            <a:r>
-              <a:rPr lang="zh-CN" sz="1050" dirty="0">
-                <a:solidFill>
-                  <a:srgbClr val="999999"/>
-                </a:solidFill>
-                <a:latin typeface="Arial"/>
-                <a:ea typeface="Microsoft YaHei"/>
-                <a:cs typeface="Arial"/>
-              </a:rPr>
-              <a:t>适配性</a:t>
-            </a:r>
-          </a:p>
-        </p:txBody>
-      </p:sp>
-      <p:sp>
-        <p:nvSpPr>
-          <p:cNvPr id="45" name="TextBox 45"/>
-          <p:cNvSpPr txBox="1"/>
-          <p:nvPr/>
-        </p:nvSpPr>
-        <p:spPr>
-          <a:xfrm>
-            <a:off x="6461760" y="4442460"/>
-            <a:ext cx="512445" cy="243840"/>
-          </a:xfrm>
-          <a:prstGeom prst="rect">
-            <a:avLst/>
-          </a:prstGeom>
-          <a:noFill/>
-          <a:ln>
-            <a:noFill/>
-          </a:ln>
-        </p:spPr>
-        <p:txBody>
-          <a:bodyPr wrap="none" lIns="0" tIns="0" rIns="0" bIns="0" anchor="t" anchorCtr="0">
-            <a:spAutoFit/>
-          </a:bodyPr>
-          <a:lstStyle/>
-          <a:p>
-            <a:pPr algn="l"/>
-            <a:r>
-              <a:rPr lang="zh-CN" sz="1200" dirty="0">
-                <a:solidFill>
-                  <a:srgbClr val="FFB800"/>
-                </a:solidFill>
-                <a:latin typeface="Arial"/>
-                <a:ea typeface="Microsoft YaHei"/>
-                <a:cs typeface="Arial"/>
-              </a:rPr>
-              <a:t>★★★★☆</a:t>
-            </a:r>
-          </a:p>
-        </p:txBody>
-      </p:sp>
-      <p:sp>
-        <p:nvSpPr>
-          <p:cNvPr id="46" name="TextBox 46"/>
-          <p:cNvSpPr txBox="1"/>
-          <p:nvPr/>
-        </p:nvSpPr>
-        <p:spPr>
-          <a:xfrm>
-            <a:off x="7321868" y="4466749"/>
-            <a:ext cx="1306354" cy="198120"/>
-          </a:xfrm>
-          <a:prstGeom prst="rect">
-            <a:avLst/>
-          </a:prstGeom>
-          <a:noFill/>
-          <a:ln>
-            <a:noFill/>
-          </a:ln>
-        </p:spPr>
-        <p:txBody>
-          <a:bodyPr wrap="none" lIns="0" tIns="0" rIns="0" bIns="0" anchor="t" anchorCtr="0">
-            <a:spAutoFit/>
-          </a:bodyPr>
-          <a:lstStyle/>
-          <a:p>
-            <a:pPr algn="l"/>
-            <a:r>
-              <a:rPr lang="zh-CN" sz="975" dirty="0">
-                <a:solidFill>
-                  <a:srgbClr val="BBBBBB"/>
-                </a:solidFill>
-                <a:latin typeface="Arial"/>
-                <a:ea typeface="Microsoft YaHei"/>
-                <a:cs typeface="Arial"/>
-              </a:rPr>
-              <a:t>美团场景辨识度极高</a:t>
-            </a:r>
-          </a:p>
-        </p:txBody>
-      </p:sp>
-      <p:sp>
-        <p:nvSpPr>
-          <p:cNvPr id="47" name="Rectangle 47"/>
-          <p:cNvSpPr/>
-          <p:nvPr/>
-        </p:nvSpPr>
-        <p:spPr>
-          <a:xfrm>
-            <a:off x="0" y="6477000"/>
-            <a:ext cx="12192000" cy="381000"/>
-          </a:xfrm>
-          <a:prstGeom prst="rect">
-            <a:avLst/>
-          </a:prstGeom>
-          <a:solidFill>
-            <a:srgbClr val="FFFFFF"/>
-          </a:solidFill>
-          <a:ln>
-            <a:noFill/>
-          </a:ln>
-        </p:spPr>
-      </p:sp>
-      <p:sp>
-        <p:nvSpPr>
-          <p:cNvPr id="48" name="Rectangle 48"/>
-          <p:cNvSpPr/>
-          <p:nvPr/>
-        </p:nvSpPr>
-        <p:spPr>
-          <a:xfrm>
-            <a:off x="0" y="6477000"/>
-            <a:ext cx="12192000" cy="9525"/>
-          </a:xfrm>
-          <a:prstGeom prst="rect">
-            <a:avLst/>
-          </a:prstGeom>
-          <a:solidFill>
-            <a:srgbClr val="F0F0F0"/>
-          </a:solidFill>
-          <a:ln>
-            <a:noFill/>
-          </a:ln>
-        </p:spPr>
-      </p:sp>
-      <p:sp>
-        <p:nvSpPr>
-          <p:cNvPr id="49" name="Freeform 49"/>
-          <p:cNvSpPr/>
-          <p:nvPr/>
-        </p:nvSpPr>
-        <p:spPr>
-          <a:xfrm>
-            <a:off x="571500" y="6572250"/>
-            <a:ext cx="209550" cy="209550"/>
-          </a:xfrm>
-          <a:custGeom>
-            <a:avLst/>
-            <a:gdLst/>
-            <a:ahLst/>
-            <a:cxnLst/>
-            <a:rect l="l" t="t" r="r" b="b"/>
-            <a:pathLst>
-              <a:path w="209550" h="209550">
-                <a:moveTo>
-                  <a:pt x="57150" y="0"/>
-                </a:moveTo>
-                <a:lnTo>
-                  <a:pt x="152400" y="0"/>
-                </a:lnTo>
-                <a:cubicBezTo>
-                  <a:pt x="183963" y="0"/>
-                  <a:pt x="209550" y="25587"/>
-                  <a:pt x="209550" y="57150"/>
-                </a:cubicBezTo>
-                <a:lnTo>
-                  <a:pt x="209550" y="152400"/>
-                </a:lnTo>
-                <a:cubicBezTo>
-                  <a:pt x="209550" y="183963"/>
-                  <a:pt x="183963" y="209550"/>
-                  <a:pt x="152400" y="209550"/>
-                </a:cubicBezTo>
-                <a:lnTo>
-                  <a:pt x="57150" y="209550"/>
-                </a:lnTo>
-                <a:cubicBezTo>
-                  <a:pt x="25587" y="209550"/>
-                  <a:pt x="0" y="183963"/>
-                  <a:pt x="0" y="152400"/>
-                </a:cubicBezTo>
-                <a:lnTo>
-                  <a:pt x="0" y="57150"/>
-                </a:lnTo>
-                <a:cubicBezTo>
-                  <a:pt x="0" y="25587"/>
-                  <a:pt x="25587" y="0"/>
-                  <a:pt x="57150" y="0"/>
-                </a:cubicBezTo>
-                <a:close/>
-              </a:path>
-            </a:pathLst>
-          </a:custGeom>
-          <a:solidFill>
-            <a:srgbClr val="FFD100"/>
-          </a:solidFill>
-          <a:ln>
-            <a:noFill/>
-          </a:ln>
-        </p:spPr>
-      </p:sp>
-      <p:sp>
-        <p:nvSpPr>
-          <p:cNvPr id="50" name="TextBox 50"/>
-          <p:cNvSpPr txBox="1"/>
-          <p:nvPr/>
-        </p:nvSpPr>
-        <p:spPr>
-          <a:xfrm>
-            <a:off x="845820" y="6627495"/>
-            <a:ext cx="285750" cy="182880"/>
-          </a:xfrm>
-          <a:prstGeom prst="rect">
-            <a:avLst/>
-          </a:prstGeom>
-          <a:noFill/>
-          <a:ln>
-            <a:noFill/>
-          </a:ln>
-        </p:spPr>
-        <p:txBody>
-          <a:bodyPr wrap="none" lIns="0" tIns="0" rIns="0" bIns="0" anchor="t" anchorCtr="0">
-            <a:spAutoFit/>
-          </a:bodyPr>
-          <a:lstStyle/>
-          <a:p>
-            <a:pPr algn="l"/>
-            <a:r>
-              <a:rPr lang="zh-CN" sz="900" dirty="0">
-                <a:solidFill>
-                  <a:srgbClr val="000000">
-                    <a:alpha val="35000"/>
-                  </a:srgbClr>
-                </a:solidFill>
-                <a:latin typeface="Arial"/>
-                <a:ea typeface="Microsoft YaHei"/>
-                <a:cs typeface="Arial"/>
-              </a:rPr>
-              <a:t>美团</a:t>
-            </a:r>
-          </a:p>
-        </p:txBody>
-      </p:sp>
-      <p:sp>
-        <p:nvSpPr>
-          <p:cNvPr id="51" name="TextBox 51"/>
-          <p:cNvSpPr txBox="1"/>
-          <p:nvPr/>
-        </p:nvSpPr>
-        <p:spPr>
-          <a:xfrm>
-            <a:off x="11273980" y="6627495"/>
-            <a:ext cx="167449" cy="182880"/>
-          </a:xfrm>
-          <a:prstGeom prst="rect">
-            <a:avLst/>
-          </a:prstGeom>
-          <a:noFill/>
-          <a:ln>
-            <a:noFill/>
-          </a:ln>
-        </p:spPr>
-        <p:txBody>
-          <a:bodyPr wrap="none" lIns="0" tIns="0" rIns="0" bIns="0" anchor="t" anchorCtr="0">
-            <a:spAutoFit/>
-          </a:bodyPr>
-          <a:lstStyle/>
-          <a:p>
-            <a:pPr algn="r"/>
-            <a:r>
-              <a:rPr lang="zh-CN" sz="900" dirty="0">
-                <a:solidFill>
-                  <a:srgbClr val="CCCCCC"/>
-                </a:solidFill>
-                <a:latin typeface="Arial"/>
-                <a:ea typeface="Microsoft YaHei"/>
-                <a:cs typeface="Arial"/>
-              </a:rPr>
-              <a:t>32</a:t>
-            </a:r>
-          </a:p>
-        </p:txBody>
-      </p:sp>
-    </p:spTree>
-  </p:cSld>
-  <p:clrMapOvr>
-    <a:masterClrMapping/>
-  </p:clrMapOvr>
-  <p:transition>
-    <p:fade/>
-  </p:transition>
-</p:sld>
-</file>
-
-<file path=ppt/slides/slide33.xml><?xml version="1.0" encoding="utf-8"?>
-<p:sld xmlns:a="http://schemas.openxmlformats.org/drawingml/2006/main" xmlns:r="http://schemas.openxmlformats.org/officeDocument/2006/relationships" xmlns:p="http://schemas.openxmlformats.org/presentationml/2006/main">
-  <p:cSld>
-    <p:spTree>
-      <p:nvGrpSpPr>
-        <p:cNvPr id="1" name=""/>
-        <p:cNvGrpSpPr/>
-        <p:nvPr/>
-      </p:nvGrpSpPr>
-      <p:grpSpPr>
-        <a:xfrm>
-          <a:off x="0" y="0"/>
-          <a:ext cx="0" cy="0"/>
-          <a:chOff x="0" y="0"/>
-          <a:chExt cx="0" cy="0"/>
-        </a:xfrm>
-      </p:grpSpPr>
-      <p:sp>
-        <p:nvSpPr>
-          <p:cNvPr id="2" name="Rectangle 2"/>
-          <p:cNvSpPr/>
-          <p:nvPr/>
-        </p:nvSpPr>
-        <p:spPr>
-          <a:xfrm>
-            <a:off x="0" y="0"/>
-            <a:ext cx="12192000" cy="6858000"/>
-          </a:xfrm>
-          <a:prstGeom prst="rect">
-            <a:avLst/>
-          </a:prstGeom>
-          <a:solidFill>
-            <a:srgbClr val="FFFFFF"/>
-          </a:solidFill>
-          <a:ln>
-            <a:noFill/>
-          </a:ln>
-        </p:spPr>
-      </p:sp>
-      <p:sp>
-        <p:nvSpPr>
-          <p:cNvPr id="3" name="Rectangle 3"/>
-          <p:cNvSpPr/>
-          <p:nvPr/>
-        </p:nvSpPr>
-        <p:spPr>
-          <a:xfrm>
-            <a:off x="0" y="0"/>
-            <a:ext cx="12192000" cy="38100"/>
-          </a:xfrm>
-          <a:prstGeom prst="rect">
-            <a:avLst/>
-          </a:prstGeom>
-          <a:solidFill>
-            <a:srgbClr val="FFD100"/>
-          </a:solidFill>
-          <a:ln>
-            <a:noFill/>
-          </a:ln>
-        </p:spPr>
-      </p:sp>
-      <p:sp>
-        <p:nvSpPr>
           <p:cNvPr id="4" name="TextBox 4"/>
           <p:cNvSpPr txBox="1"/>
           <p:nvPr/>
@@ -35275,86 +32322,6 @@
       </p:sp>
       <p:sp>
         <p:nvSpPr>
-          <p:cNvPr id="32" name="TextBox 32"/>
-          <p:cNvSpPr txBox="1"/>
-          <p:nvPr/>
-        </p:nvSpPr>
-        <p:spPr>
-          <a:xfrm>
-            <a:off x="4559618" y="4323548"/>
-            <a:ext cx="622840" cy="198120"/>
-          </a:xfrm>
-          <a:prstGeom prst="rect">
-            <a:avLst/>
-          </a:prstGeom>
-          <a:noFill/>
-          <a:ln>
-            <a:noFill/>
-          </a:ln>
-        </p:spPr>
-        <p:txBody>
-          <a:bodyPr wrap="none" lIns="0" tIns="0" rIns="0" bIns="0" anchor="t" anchorCtr="0">
-            <a:spAutoFit/>
-          </a:bodyPr>
-          <a:lstStyle/>
-          <a:p>
-            <a:pPr algn="l"/>
-            <a:r>
-              <a:rPr lang="zh-CN" sz="975" b="1" dirty="0">
-                <a:solidFill>
-                  <a:srgbClr val="000000"/>
-                </a:solidFill>
-                <a:latin typeface="Arial"/>
-                <a:ea typeface="Microsoft YaHei"/>
-                <a:cs typeface="Arial"/>
-              </a:rPr>
-              <a:t>美团业务</a:t>
-            </a:r>
-          </a:p>
-        </p:txBody>
-      </p:sp>
-      <p:sp>
-        <p:nvSpPr>
-          <p:cNvPr id="33" name="TextBox 33"/>
-          <p:cNvSpPr txBox="1"/>
-          <p:nvPr/>
-        </p:nvSpPr>
-        <p:spPr>
-          <a:xfrm>
-            <a:off x="4560570" y="4522144"/>
-            <a:ext cx="2106263" cy="182880"/>
-          </a:xfrm>
-          <a:prstGeom prst="rect">
-            <a:avLst/>
-          </a:prstGeom>
-          <a:noFill/>
-          <a:ln>
-            <a:noFill/>
-          </a:ln>
-        </p:spPr>
-        <p:txBody>
-          <a:bodyPr wrap="none" lIns="0" tIns="0" rIns="0" bIns="0" anchor="t" anchorCtr="0">
-            <a:spAutoFit/>
-          </a:bodyPr>
-          <a:lstStyle/>
-          <a:p>
-            <a:pPr algn="l"/>
-            <a:r>
-              <a:rPr lang="zh-CN" sz="900" dirty="0">
-                <a:solidFill>
-                  <a:srgbClr val="666666"/>
-                </a:solidFill>
-                <a:latin typeface="Arial"/>
-                <a:ea typeface="Microsoft YaHei"/>
-                <a:cs typeface="Arial"/>
-              </a:rPr>
-              <a:t>Meituan · Pentagram · Fukasawa</a:t>
-            </a:r>
-          </a:p>
-        </p:txBody>
-      </p:sp>
-      <p:sp>
-        <p:nvSpPr>
           <p:cNvPr id="34" name="Freeform 34"/>
           <p:cNvSpPr/>
           <p:nvPr/>
@@ -36048,7 +33015,7 @@
         <p:spPr>
           <a:xfrm>
             <a:off x="845820" y="6627495"/>
-            <a:ext cx="1685639" cy="182880"/>
+            <a:ext cx="384721" cy="138499"/>
           </a:xfrm>
           <a:prstGeom prst="rect">
             <a:avLst/>
@@ -36076,7 +33043,33 @@
                 <a:ea typeface="Microsoft YaHei"/>
                 <a:cs typeface="Arial"/>
               </a:rPr>
-              <a:t>PPT 大师 · mu-ppt-master</a:t>
+              <a:t>mu-</a:t>
+            </a:r>
+            <a:r>
+              <a:rPr lang="en-US" altLang="zh-CN" sz="900" dirty="0" err="1">
+                <a:solidFill>
+                  <a:srgbClr val="000000">
+                    <a:alpha val="35000"/>
+                  </a:srgbClr>
+                </a:solidFill>
+                <a:latin typeface="Arial"/>
+                <a:ea typeface="Microsoft YaHei"/>
+                <a:cs typeface="Arial"/>
+              </a:rPr>
+              <a:t>i</a:t>
+            </a:r>
+            <a:r>
+              <a:rPr lang="zh-CN" sz="900" dirty="0">
+                <a:solidFill>
+                  <a:srgbClr val="000000">
+                    <a:alpha val="35000"/>
+                  </a:srgbClr>
+                </a:solidFill>
+                <a:latin typeface="Arial"/>
+                <a:ea typeface="Microsoft YaHei"/>
+                <a:cs typeface="Arial"/>
+              </a:rPr>
+              <a:t>ppt</a:t>
             </a:r>
           </a:p>
         </p:txBody>

</xml_diff>

<commit_message>
update: refresh design philosophies PPTX example
</commit_message>
<xml_diff>
--- a/examples/design-philosophies/muippt-design-philosophies_202606.pptx
+++ b/examples/design-philosophies/muippt-design-philosophies_202606.pptx
@@ -19343,166 +19343,6 @@
                 <a:cs typeface="Arial"/>
               </a:rPr>
               <a:t>14 Fukasawa 无意识设计</a:t>
-            </a:r>
-          </a:p>
-        </p:txBody>
-      </p:sp>
-      <p:sp>
-        <p:nvSpPr>
-          <p:cNvPr id="35" name="TextBox 35"/>
-          <p:cNvSpPr txBox="1"/>
-          <p:nvPr/>
-        </p:nvSpPr>
-        <p:spPr>
-          <a:xfrm>
-            <a:off x="8369618" y="3990499"/>
-            <a:ext cx="473321" cy="198120"/>
-          </a:xfrm>
-          <a:prstGeom prst="rect">
-            <a:avLst/>
-          </a:prstGeom>
-          <a:noFill/>
-          <a:ln>
-            <a:noFill/>
-          </a:ln>
-        </p:spPr>
-        <p:txBody>
-          <a:bodyPr wrap="none" lIns="0" tIns="0" rIns="0" bIns="0" anchor="t" anchorCtr="0">
-            <a:spAutoFit/>
-          </a:bodyPr>
-          <a:lstStyle/>
-          <a:p>
-            <a:pPr algn="l"/>
-            <a:r>
-              <a:rPr lang="zh-CN" sz="975" b="1" dirty="0">
-                <a:solidFill>
-                  <a:srgbClr val="C41E3A"/>
-                </a:solidFill>
-                <a:latin typeface="Arial"/>
-                <a:ea typeface="Microsoft YaHei"/>
-                <a:cs typeface="Arial"/>
-              </a:rPr>
-              <a:t>流派六</a:t>
-            </a:r>
-          </a:p>
-        </p:txBody>
-      </p:sp>
-      <p:sp>
-        <p:nvSpPr>
-          <p:cNvPr id="36" name="TextBox 36"/>
-          <p:cNvSpPr txBox="1"/>
-          <p:nvPr/>
-        </p:nvSpPr>
-        <p:spPr>
-          <a:xfrm>
-            <a:off x="8361045" y="4165282"/>
-            <a:ext cx="1054036" cy="335280"/>
-          </a:xfrm>
-          <a:prstGeom prst="rect">
-            <a:avLst/>
-          </a:prstGeom>
-          <a:noFill/>
-          <a:ln>
-            <a:noFill/>
-          </a:ln>
-        </p:spPr>
-        <p:txBody>
-          <a:bodyPr wrap="none" lIns="0" tIns="0" rIns="0" bIns="0" anchor="t" anchorCtr="0">
-            <a:spAutoFit/>
-          </a:bodyPr>
-          <a:lstStyle/>
-          <a:p>
-            <a:pPr algn="l"/>
-            <a:r>
-              <a:rPr lang="zh-CN" sz="1650" b="1" dirty="0">
-                <a:solidFill>
-                  <a:srgbClr val="003366"/>
-                </a:solidFill>
-                <a:latin typeface="Arial"/>
-                <a:ea typeface="Microsoft YaHei"/>
-                <a:cs typeface="Arial"/>
-              </a:rPr>
-              <a:t>品牌原生</a:t>
-            </a:r>
-          </a:p>
-        </p:txBody>
-      </p:sp>
-      <p:sp>
-        <p:nvSpPr>
-          <p:cNvPr id="37" name="TextBox 37"/>
-          <p:cNvSpPr txBox="1"/>
-          <p:nvPr/>
-        </p:nvSpPr>
-        <p:spPr>
-          <a:xfrm>
-            <a:off x="8369618" y="4447699"/>
-            <a:ext cx="1491472" cy="198120"/>
-          </a:xfrm>
-          <a:prstGeom prst="rect">
-            <a:avLst/>
-          </a:prstGeom>
-          <a:noFill/>
-          <a:ln>
-            <a:noFill/>
-          </a:ln>
-        </p:spPr>
-        <p:txBody>
-          <a:bodyPr wrap="none" lIns="0" tIns="0" rIns="0" bIns="0" anchor="t" anchorCtr="0">
-            <a:spAutoFit/>
-          </a:bodyPr>
-          <a:lstStyle/>
-          <a:p>
-            <a:pPr algn="l"/>
-            <a:r>
-              <a:rPr lang="zh-CN" sz="975" dirty="0">
-                <a:solidFill>
-                  <a:srgbClr val="888888"/>
-                </a:solidFill>
-                <a:latin typeface="Arial"/>
-                <a:ea typeface="Microsoft YaHei"/>
-                <a:cs typeface="Arial"/>
-              </a:rPr>
-              <a:t>品牌原生 · 年轻 · 温暖</a:t>
-            </a:r>
-          </a:p>
-        </p:txBody>
-      </p:sp>
-      <p:sp>
-        <p:nvSpPr>
-          <p:cNvPr id="38" name="TextBox 38"/>
-          <p:cNvSpPr txBox="1"/>
-          <p:nvPr/>
-        </p:nvSpPr>
-        <p:spPr>
-          <a:xfrm>
-            <a:off x="8367712" y="4698206"/>
-            <a:ext cx="1548408" cy="228600"/>
-          </a:xfrm>
-          <a:prstGeom prst="rect">
-            <a:avLst/>
-          </a:prstGeom>
-          <a:noFill/>
-          <a:ln>
-            <a:noFill/>
-          </a:ln>
-        </p:spPr>
-        <p:txBody>
-          <a:bodyPr wrap="none" lIns="0" tIns="0" rIns="0" bIns="0" anchor="t" anchorCtr="0">
-            <a:spAutoFit/>
-          </a:bodyPr>
-          <a:lstStyle/>
-          <a:p>
-            <a:pPr algn="l"/>
-            <a:r>
-              <a:rPr lang="zh-CN" sz="1125" dirty="0">
-                <a:solidFill>
-                  <a:srgbClr val="444444"/>
-                </a:solidFill>
-                <a:latin typeface="Arial"/>
-                <a:ea typeface="Microsoft YaHei"/>
-                <a:cs typeface="Arial"/>
-              </a:rPr>
-              <a:t>15 Meituan 阳光活力</a:t>
             </a:r>
           </a:p>
         </p:txBody>

</xml_diff>